<commit_message>
Add perovskite parameter-space figure; update proposal writeup slides
</commit_message>
<xml_diff>
--- a/preposal_writeup/Inverse_solution_fig.pptx
+++ b/preposal_writeup/Inverse_solution_fig.pptx
@@ -2,15 +2,17 @@
 <file path=ppt/presentation.xml><?xml version="1.0" encoding="utf-8"?>
 <p:presentation xmlns:a="http://schemas.openxmlformats.org/drawingml/2006/main" xmlns:r="http://schemas.openxmlformats.org/officeDocument/2006/relationships" xmlns:p="http://schemas.openxmlformats.org/presentationml/2006/main" saveSubsetFonts="1" autoCompressPictures="0">
   <p:sldMasterIdLst>
-    <p:sldMasterId id="2147483696" r:id="rId1"/>
+    <p:sldMasterId id="2147483708" r:id="rId1"/>
   </p:sldMasterIdLst>
   <p:notesMasterIdLst>
-    <p:notesMasterId r:id="rId3"/>
+    <p:notesMasterId r:id="rId5"/>
   </p:notesMasterIdLst>
   <p:sldIdLst>
     <p:sldId id="256" r:id="rId2"/>
+    <p:sldId id="257" r:id="rId3"/>
+    <p:sldId id="258" r:id="rId4"/>
   </p:sldIdLst>
-  <p:sldSz cx="3090863" cy="7772400"/>
+  <p:sldSz cx="5943600" cy="7772400"/>
   <p:notesSz cx="6858000" cy="9144000"/>
   <p:defaultTextStyle>
     <a:defPPr>
@@ -197,7 +199,7 @@
           <a:p>
             <a:fld id="{0FF2B54D-5177-0F43-A881-7627635DD56E}" type="datetimeFigureOut">
               <a:rPr lang="en-US" smtClean="0"/>
-              <a:t>4/22/26</a:t>
+              <a:t>4/27/26</a:t>
             </a:fld>
             <a:endParaRPr lang="en-US"/>
           </a:p>
@@ -215,8 +217,8 @@
         </p:nvSpPr>
         <p:spPr>
           <a:xfrm>
-            <a:off x="2814638" y="1143000"/>
-            <a:ext cx="1228725" cy="3086100"/>
+            <a:off x="2249488" y="1143000"/>
+            <a:ext cx="2359025" cy="3086100"/>
           </a:xfrm>
           <a:prstGeom prst="rect">
             <a:avLst/>
@@ -491,7 +493,12 @@
             <p:ph type="sldImg"/>
           </p:nvPr>
         </p:nvSpPr>
-        <p:spPr/>
+        <p:spPr>
+          <a:xfrm>
+            <a:off x="2249488" y="1143000"/>
+            <a:ext cx="2359025" cy="3086100"/>
+          </a:xfrm>
+        </p:spPr>
       </p:sp>
       <p:sp>
         <p:nvSpPr>
@@ -558,6 +565,90 @@
     <p:extLst>
       <p:ext uri="{BB962C8B-B14F-4D97-AF65-F5344CB8AC3E}">
         <p14:creationId xmlns:p14="http://schemas.microsoft.com/office/powerpoint/2010/main" val="378892061"/>
+      </p:ext>
+    </p:extLst>
+  </p:cSld>
+  <p:clrMapOvr>
+    <a:masterClrMapping/>
+  </p:clrMapOvr>
+</p:notes>
+</file>
+
+<file path=ppt/notesSlides/notesSlide2.xml><?xml version="1.0" encoding="utf-8"?>
+<p:notes xmlns:a="http://schemas.openxmlformats.org/drawingml/2006/main" xmlns:r="http://schemas.openxmlformats.org/officeDocument/2006/relationships" xmlns:p="http://schemas.openxmlformats.org/presentationml/2006/main">
+  <p:cSld>
+    <p:spTree>
+      <p:nvGrpSpPr>
+        <p:cNvPr id="1" name=""/>
+        <p:cNvGrpSpPr/>
+        <p:nvPr/>
+      </p:nvGrpSpPr>
+      <p:grpSpPr>
+        <a:xfrm>
+          <a:off x="0" y="0"/>
+          <a:ext cx="0" cy="0"/>
+          <a:chOff x="0" y="0"/>
+          <a:chExt cx="0" cy="0"/>
+        </a:xfrm>
+      </p:grpSpPr>
+      <p:sp>
+        <p:nvSpPr>
+          <p:cNvPr id="2" name="Slide Image Placeholder 1"/>
+          <p:cNvSpPr>
+            <a:spLocks noGrp="1" noRot="1" noChangeAspect="1"/>
+          </p:cNvSpPr>
+          <p:nvPr>
+            <p:ph type="sldImg"/>
+          </p:nvPr>
+        </p:nvSpPr>
+        <p:spPr/>
+      </p:sp>
+      <p:sp>
+        <p:nvSpPr>
+          <p:cNvPr id="3" name="Notes Placeholder 2"/>
+          <p:cNvSpPr>
+            <a:spLocks noGrp="1"/>
+          </p:cNvSpPr>
+          <p:nvPr>
+            <p:ph type="body" idx="1"/>
+          </p:nvPr>
+        </p:nvSpPr>
+        <p:spPr/>
+        <p:txBody>
+          <a:bodyPr/>
+          <a:lstStyle/>
+          <a:p>
+            <a:endParaRPr lang="en-US" dirty="0"/>
+          </a:p>
+        </p:txBody>
+      </p:sp>
+      <p:sp>
+        <p:nvSpPr>
+          <p:cNvPr id="4" name="Slide Number Placeholder 3"/>
+          <p:cNvSpPr>
+            <a:spLocks noGrp="1"/>
+          </p:cNvSpPr>
+          <p:nvPr>
+            <p:ph type="sldNum" sz="quarter" idx="5"/>
+          </p:nvPr>
+        </p:nvSpPr>
+        <p:spPr/>
+        <p:txBody>
+          <a:bodyPr/>
+          <a:lstStyle/>
+          <a:p>
+            <a:fld id="{4E0FE671-F752-BB4A-AC58-5573ACA2A586}" type="slidenum">
+              <a:rPr lang="en-US" smtClean="0"/>
+              <a:t>3</a:t>
+            </a:fld>
+            <a:endParaRPr lang="en-US"/>
+          </a:p>
+        </p:txBody>
+      </p:sp>
+    </p:spTree>
+    <p:extLst>
+      <p:ext uri="{BB962C8B-B14F-4D97-AF65-F5344CB8AC3E}">
+        <p14:creationId xmlns:p14="http://schemas.microsoft.com/office/powerpoint/2010/main" val="2243503604"/>
       </p:ext>
     </p:extLst>
   </p:cSld>
@@ -596,15 +687,15 @@
         </p:nvSpPr>
         <p:spPr>
           <a:xfrm>
-            <a:off x="231815" y="1272011"/>
-            <a:ext cx="2627234" cy="2705947"/>
+            <a:off x="445770" y="1272011"/>
+            <a:ext cx="5052060" cy="2705947"/>
           </a:xfrm>
         </p:spPr>
         <p:txBody>
           <a:bodyPr anchor="b"/>
           <a:lstStyle>
             <a:lvl1pPr algn="ctr">
-              <a:defRPr sz="2028"/>
+              <a:defRPr sz="3900"/>
             </a:lvl1pPr>
           </a:lstStyle>
           <a:p>
@@ -628,8 +719,8 @@
         </p:nvSpPr>
         <p:spPr>
           <a:xfrm>
-            <a:off x="386358" y="4082310"/>
-            <a:ext cx="2318147" cy="1876530"/>
+            <a:off x="742950" y="4082310"/>
+            <a:ext cx="4457700" cy="1876530"/>
           </a:xfrm>
         </p:spPr>
         <p:txBody>
@@ -637,39 +728,39 @@
           <a:lstStyle>
             <a:lvl1pPr marL="0" indent="0" algn="ctr">
               <a:buNone/>
-              <a:defRPr sz="811"/>
+              <a:defRPr sz="1560"/>
             </a:lvl1pPr>
-            <a:lvl2pPr marL="154534" indent="0" algn="ctr">
-              <a:buNone/>
-              <a:defRPr sz="676"/>
+            <a:lvl2pPr marL="297180" indent="0" algn="ctr">
+              <a:buNone/>
+              <a:defRPr sz="1300"/>
             </a:lvl2pPr>
-            <a:lvl3pPr marL="309067" indent="0" algn="ctr">
-              <a:buNone/>
-              <a:defRPr sz="608"/>
+            <a:lvl3pPr marL="594360" indent="0" algn="ctr">
+              <a:buNone/>
+              <a:defRPr sz="1170"/>
             </a:lvl3pPr>
-            <a:lvl4pPr marL="463601" indent="0" algn="ctr">
-              <a:buNone/>
-              <a:defRPr sz="541"/>
+            <a:lvl4pPr marL="891540" indent="0" algn="ctr">
+              <a:buNone/>
+              <a:defRPr sz="1040"/>
             </a:lvl4pPr>
-            <a:lvl5pPr marL="618134" indent="0" algn="ctr">
-              <a:buNone/>
-              <a:defRPr sz="541"/>
+            <a:lvl5pPr marL="1188720" indent="0" algn="ctr">
+              <a:buNone/>
+              <a:defRPr sz="1040"/>
             </a:lvl5pPr>
-            <a:lvl6pPr marL="772668" indent="0" algn="ctr">
-              <a:buNone/>
-              <a:defRPr sz="541"/>
+            <a:lvl6pPr marL="1485900" indent="0" algn="ctr">
+              <a:buNone/>
+              <a:defRPr sz="1040"/>
             </a:lvl6pPr>
-            <a:lvl7pPr marL="927202" indent="0" algn="ctr">
-              <a:buNone/>
-              <a:defRPr sz="541"/>
+            <a:lvl7pPr marL="1783080" indent="0" algn="ctr">
+              <a:buNone/>
+              <a:defRPr sz="1040"/>
             </a:lvl7pPr>
-            <a:lvl8pPr marL="1081735" indent="0" algn="ctr">
-              <a:buNone/>
-              <a:defRPr sz="541"/>
+            <a:lvl8pPr marL="2080260" indent="0" algn="ctr">
+              <a:buNone/>
+              <a:defRPr sz="1040"/>
             </a:lvl8pPr>
-            <a:lvl9pPr marL="1236269" indent="0" algn="ctr">
-              <a:buNone/>
-              <a:defRPr sz="541"/>
+            <a:lvl9pPr marL="2377440" indent="0" algn="ctr">
+              <a:buNone/>
+              <a:defRPr sz="1040"/>
             </a:lvl9pPr>
           </a:lstStyle>
           <a:p>
@@ -698,7 +789,7 @@
           <a:p>
             <a:fld id="{94060ED0-D23E-A044-9972-B94295700C82}" type="datetimeFigureOut">
               <a:rPr lang="en-US" smtClean="0"/>
-              <a:t>4/22/26</a:t>
+              <a:t>4/27/26</a:t>
             </a:fld>
             <a:endParaRPr lang="en-US"/>
           </a:p>
@@ -749,7 +840,7 @@
     </p:spTree>
     <p:extLst>
       <p:ext uri="{BB962C8B-B14F-4D97-AF65-F5344CB8AC3E}">
-        <p14:creationId xmlns:p14="http://schemas.microsoft.com/office/powerpoint/2010/main" val="2317657724"/>
+        <p14:creationId xmlns:p14="http://schemas.microsoft.com/office/powerpoint/2010/main" val="2146192447"/>
       </p:ext>
     </p:extLst>
   </p:cSld>
@@ -868,7 +959,7 @@
           <a:p>
             <a:fld id="{94060ED0-D23E-A044-9972-B94295700C82}" type="datetimeFigureOut">
               <a:rPr lang="en-US" smtClean="0"/>
-              <a:t>4/22/26</a:t>
+              <a:t>4/27/26</a:t>
             </a:fld>
             <a:endParaRPr lang="en-US"/>
           </a:p>
@@ -919,7 +1010,7 @@
     </p:spTree>
     <p:extLst>
       <p:ext uri="{BB962C8B-B14F-4D97-AF65-F5344CB8AC3E}">
-        <p14:creationId xmlns:p14="http://schemas.microsoft.com/office/powerpoint/2010/main" val="478591212"/>
+        <p14:creationId xmlns:p14="http://schemas.microsoft.com/office/powerpoint/2010/main" val="2039955457"/>
       </p:ext>
     </p:extLst>
   </p:cSld>
@@ -958,8 +1049,8 @@
         </p:nvSpPr>
         <p:spPr>
           <a:xfrm>
-            <a:off x="2211899" y="413808"/>
-            <a:ext cx="666467" cy="6586750"/>
+            <a:off x="4253389" y="413808"/>
+            <a:ext cx="1281589" cy="6586750"/>
           </a:xfrm>
         </p:spPr>
         <p:txBody>
@@ -986,8 +1077,8 @@
         </p:nvSpPr>
         <p:spPr>
           <a:xfrm>
-            <a:off x="212497" y="413808"/>
-            <a:ext cx="1960766" cy="6586750"/>
+            <a:off x="408623" y="413808"/>
+            <a:ext cx="3770471" cy="6586750"/>
           </a:xfrm>
         </p:spPr>
         <p:txBody>
@@ -1048,7 +1139,7 @@
           <a:p>
             <a:fld id="{94060ED0-D23E-A044-9972-B94295700C82}" type="datetimeFigureOut">
               <a:rPr lang="en-US" smtClean="0"/>
-              <a:t>4/22/26</a:t>
+              <a:t>4/27/26</a:t>
             </a:fld>
             <a:endParaRPr lang="en-US"/>
           </a:p>
@@ -1099,7 +1190,7 @@
     </p:spTree>
     <p:extLst>
       <p:ext uri="{BB962C8B-B14F-4D97-AF65-F5344CB8AC3E}">
-        <p14:creationId xmlns:p14="http://schemas.microsoft.com/office/powerpoint/2010/main" val="4290642888"/>
+        <p14:creationId xmlns:p14="http://schemas.microsoft.com/office/powerpoint/2010/main" val="3104540268"/>
       </p:ext>
     </p:extLst>
   </p:cSld>
@@ -1218,7 +1309,7 @@
           <a:p>
             <a:fld id="{94060ED0-D23E-A044-9972-B94295700C82}" type="datetimeFigureOut">
               <a:rPr lang="en-US" smtClean="0"/>
-              <a:t>4/22/26</a:t>
+              <a:t>4/27/26</a:t>
             </a:fld>
             <a:endParaRPr lang="en-US"/>
           </a:p>
@@ -1269,7 +1360,7 @@
     </p:spTree>
     <p:extLst>
       <p:ext uri="{BB962C8B-B14F-4D97-AF65-F5344CB8AC3E}">
-        <p14:creationId xmlns:p14="http://schemas.microsoft.com/office/powerpoint/2010/main" val="3676406858"/>
+        <p14:creationId xmlns:p14="http://schemas.microsoft.com/office/powerpoint/2010/main" val="2270662886"/>
       </p:ext>
     </p:extLst>
   </p:cSld>
@@ -1308,15 +1399,15 @@
         </p:nvSpPr>
         <p:spPr>
           <a:xfrm>
-            <a:off x="210887" y="1937705"/>
-            <a:ext cx="2665869" cy="3233102"/>
+            <a:off x="405527" y="1937705"/>
+            <a:ext cx="5126355" cy="3233102"/>
           </a:xfrm>
         </p:spPr>
         <p:txBody>
           <a:bodyPr anchor="b"/>
           <a:lstStyle>
             <a:lvl1pPr>
-              <a:defRPr sz="2028"/>
+              <a:defRPr sz="3900"/>
             </a:lvl1pPr>
           </a:lstStyle>
           <a:p>
@@ -1340,8 +1431,8 @@
         </p:nvSpPr>
         <p:spPr>
           <a:xfrm>
-            <a:off x="210887" y="5201393"/>
-            <a:ext cx="2665869" cy="1700212"/>
+            <a:off x="405527" y="5201393"/>
+            <a:ext cx="5126355" cy="1700212"/>
           </a:xfrm>
         </p:spPr>
         <p:txBody>
@@ -1349,7 +1440,7 @@
           <a:lstStyle>
             <a:lvl1pPr marL="0" indent="0">
               <a:buNone/>
-              <a:defRPr sz="811">
+              <a:defRPr sz="1560">
                 <a:solidFill>
                   <a:schemeClr val="tx1">
                     <a:tint val="82000"/>
@@ -1357,9 +1448,9 @@
                 </a:solidFill>
               </a:defRPr>
             </a:lvl1pPr>
-            <a:lvl2pPr marL="154534" indent="0">
-              <a:buNone/>
-              <a:defRPr sz="676">
+            <a:lvl2pPr marL="297180" indent="0">
+              <a:buNone/>
+              <a:defRPr sz="1300">
                 <a:solidFill>
                   <a:schemeClr val="tx1">
                     <a:tint val="82000"/>
@@ -1367,9 +1458,9 @@
                 </a:solidFill>
               </a:defRPr>
             </a:lvl2pPr>
-            <a:lvl3pPr marL="309067" indent="0">
-              <a:buNone/>
-              <a:defRPr sz="608">
+            <a:lvl3pPr marL="594360" indent="0">
+              <a:buNone/>
+              <a:defRPr sz="1170">
                 <a:solidFill>
                   <a:schemeClr val="tx1">
                     <a:tint val="82000"/>
@@ -1377,9 +1468,9 @@
                 </a:solidFill>
               </a:defRPr>
             </a:lvl3pPr>
-            <a:lvl4pPr marL="463601" indent="0">
-              <a:buNone/>
-              <a:defRPr sz="541">
+            <a:lvl4pPr marL="891540" indent="0">
+              <a:buNone/>
+              <a:defRPr sz="1040">
                 <a:solidFill>
                   <a:schemeClr val="tx1">
                     <a:tint val="82000"/>
@@ -1387,9 +1478,9 @@
                 </a:solidFill>
               </a:defRPr>
             </a:lvl4pPr>
-            <a:lvl5pPr marL="618134" indent="0">
-              <a:buNone/>
-              <a:defRPr sz="541">
+            <a:lvl5pPr marL="1188720" indent="0">
+              <a:buNone/>
+              <a:defRPr sz="1040">
                 <a:solidFill>
                   <a:schemeClr val="tx1">
                     <a:tint val="82000"/>
@@ -1397,9 +1488,9 @@
                 </a:solidFill>
               </a:defRPr>
             </a:lvl5pPr>
-            <a:lvl6pPr marL="772668" indent="0">
-              <a:buNone/>
-              <a:defRPr sz="541">
+            <a:lvl6pPr marL="1485900" indent="0">
+              <a:buNone/>
+              <a:defRPr sz="1040">
                 <a:solidFill>
                   <a:schemeClr val="tx1">
                     <a:tint val="82000"/>
@@ -1407,9 +1498,9 @@
                 </a:solidFill>
               </a:defRPr>
             </a:lvl6pPr>
-            <a:lvl7pPr marL="927202" indent="0">
-              <a:buNone/>
-              <a:defRPr sz="541">
+            <a:lvl7pPr marL="1783080" indent="0">
+              <a:buNone/>
+              <a:defRPr sz="1040">
                 <a:solidFill>
                   <a:schemeClr val="tx1">
                     <a:tint val="82000"/>
@@ -1417,9 +1508,9 @@
                 </a:solidFill>
               </a:defRPr>
             </a:lvl7pPr>
-            <a:lvl8pPr marL="1081735" indent="0">
-              <a:buNone/>
-              <a:defRPr sz="541">
+            <a:lvl8pPr marL="2080260" indent="0">
+              <a:buNone/>
+              <a:defRPr sz="1040">
                 <a:solidFill>
                   <a:schemeClr val="tx1">
                     <a:tint val="82000"/>
@@ -1427,9 +1518,9 @@
                 </a:solidFill>
               </a:defRPr>
             </a:lvl8pPr>
-            <a:lvl9pPr marL="1236269" indent="0">
-              <a:buNone/>
-              <a:defRPr sz="541">
+            <a:lvl9pPr marL="2377440" indent="0">
+              <a:buNone/>
+              <a:defRPr sz="1040">
                 <a:solidFill>
                   <a:schemeClr val="tx1">
                     <a:tint val="82000"/>
@@ -1464,7 +1555,7 @@
           <a:p>
             <a:fld id="{94060ED0-D23E-A044-9972-B94295700C82}" type="datetimeFigureOut">
               <a:rPr lang="en-US" smtClean="0"/>
-              <a:t>4/22/26</a:t>
+              <a:t>4/27/26</a:t>
             </a:fld>
             <a:endParaRPr lang="en-US"/>
           </a:p>
@@ -1515,7 +1606,7 @@
     </p:spTree>
     <p:extLst>
       <p:ext uri="{BB962C8B-B14F-4D97-AF65-F5344CB8AC3E}">
-        <p14:creationId xmlns:p14="http://schemas.microsoft.com/office/powerpoint/2010/main" val="3518208967"/>
+        <p14:creationId xmlns:p14="http://schemas.microsoft.com/office/powerpoint/2010/main" val="12255204"/>
       </p:ext>
     </p:extLst>
   </p:cSld>
@@ -1577,8 +1668,8 @@
         </p:nvSpPr>
         <p:spPr>
           <a:xfrm>
-            <a:off x="212497" y="2069042"/>
-            <a:ext cx="1313617" cy="4931516"/>
+            <a:off x="408623" y="2069042"/>
+            <a:ext cx="2526030" cy="4931516"/>
           </a:xfrm>
         </p:spPr>
         <p:txBody>
@@ -1634,8 +1725,8 @@
         </p:nvSpPr>
         <p:spPr>
           <a:xfrm>
-            <a:off x="1564749" y="2069042"/>
-            <a:ext cx="1313617" cy="4931516"/>
+            <a:off x="3008948" y="2069042"/>
+            <a:ext cx="2526030" cy="4931516"/>
           </a:xfrm>
         </p:spPr>
         <p:txBody>
@@ -1696,7 +1787,7 @@
           <a:p>
             <a:fld id="{94060ED0-D23E-A044-9972-B94295700C82}" type="datetimeFigureOut">
               <a:rPr lang="en-US" smtClean="0"/>
-              <a:t>4/22/26</a:t>
+              <a:t>4/27/26</a:t>
             </a:fld>
             <a:endParaRPr lang="en-US"/>
           </a:p>
@@ -1747,7 +1838,7 @@
     </p:spTree>
     <p:extLst>
       <p:ext uri="{BB962C8B-B14F-4D97-AF65-F5344CB8AC3E}">
-        <p14:creationId xmlns:p14="http://schemas.microsoft.com/office/powerpoint/2010/main" val="119525023"/>
+        <p14:creationId xmlns:p14="http://schemas.microsoft.com/office/powerpoint/2010/main" val="1695172402"/>
       </p:ext>
     </p:extLst>
   </p:cSld>
@@ -1786,8 +1877,8 @@
         </p:nvSpPr>
         <p:spPr>
           <a:xfrm>
-            <a:off x="212900" y="413810"/>
-            <a:ext cx="2665869" cy="1502305"/>
+            <a:off x="409397" y="413810"/>
+            <a:ext cx="5126355" cy="1502305"/>
           </a:xfrm>
         </p:spPr>
         <p:txBody>
@@ -1814,8 +1905,8 @@
         </p:nvSpPr>
         <p:spPr>
           <a:xfrm>
-            <a:off x="212900" y="1905318"/>
-            <a:ext cx="1307580" cy="933767"/>
+            <a:off x="409397" y="1905318"/>
+            <a:ext cx="2514421" cy="933767"/>
           </a:xfrm>
         </p:spPr>
         <p:txBody>
@@ -1823,39 +1914,39 @@
           <a:lstStyle>
             <a:lvl1pPr marL="0" indent="0">
               <a:buNone/>
-              <a:defRPr sz="811" b="1"/>
+              <a:defRPr sz="1560" b="1"/>
             </a:lvl1pPr>
-            <a:lvl2pPr marL="154534" indent="0">
-              <a:buNone/>
-              <a:defRPr sz="676" b="1"/>
+            <a:lvl2pPr marL="297180" indent="0">
+              <a:buNone/>
+              <a:defRPr sz="1300" b="1"/>
             </a:lvl2pPr>
-            <a:lvl3pPr marL="309067" indent="0">
-              <a:buNone/>
-              <a:defRPr sz="608" b="1"/>
+            <a:lvl3pPr marL="594360" indent="0">
+              <a:buNone/>
+              <a:defRPr sz="1170" b="1"/>
             </a:lvl3pPr>
-            <a:lvl4pPr marL="463601" indent="0">
-              <a:buNone/>
-              <a:defRPr sz="541" b="1"/>
+            <a:lvl4pPr marL="891540" indent="0">
+              <a:buNone/>
+              <a:defRPr sz="1040" b="1"/>
             </a:lvl4pPr>
-            <a:lvl5pPr marL="618134" indent="0">
-              <a:buNone/>
-              <a:defRPr sz="541" b="1"/>
+            <a:lvl5pPr marL="1188720" indent="0">
+              <a:buNone/>
+              <a:defRPr sz="1040" b="1"/>
             </a:lvl5pPr>
-            <a:lvl6pPr marL="772668" indent="0">
-              <a:buNone/>
-              <a:defRPr sz="541" b="1"/>
+            <a:lvl6pPr marL="1485900" indent="0">
+              <a:buNone/>
+              <a:defRPr sz="1040" b="1"/>
             </a:lvl6pPr>
-            <a:lvl7pPr marL="927202" indent="0">
-              <a:buNone/>
-              <a:defRPr sz="541" b="1"/>
+            <a:lvl7pPr marL="1783080" indent="0">
+              <a:buNone/>
+              <a:defRPr sz="1040" b="1"/>
             </a:lvl7pPr>
-            <a:lvl8pPr marL="1081735" indent="0">
-              <a:buNone/>
-              <a:defRPr sz="541" b="1"/>
+            <a:lvl8pPr marL="2080260" indent="0">
+              <a:buNone/>
+              <a:defRPr sz="1040" b="1"/>
             </a:lvl8pPr>
-            <a:lvl9pPr marL="1236269" indent="0">
-              <a:buNone/>
-              <a:defRPr sz="541" b="1"/>
+            <a:lvl9pPr marL="2377440" indent="0">
+              <a:buNone/>
+              <a:defRPr sz="1040" b="1"/>
             </a:lvl9pPr>
           </a:lstStyle>
           <a:p>
@@ -1879,8 +1970,8 @@
         </p:nvSpPr>
         <p:spPr>
           <a:xfrm>
-            <a:off x="212900" y="2839085"/>
-            <a:ext cx="1307580" cy="4175866"/>
+            <a:off x="409397" y="2839085"/>
+            <a:ext cx="2514421" cy="4175866"/>
           </a:xfrm>
         </p:spPr>
         <p:txBody>
@@ -1936,8 +2027,8 @@
         </p:nvSpPr>
         <p:spPr>
           <a:xfrm>
-            <a:off x="1564750" y="1905318"/>
-            <a:ext cx="1314019" cy="933767"/>
+            <a:off x="3008948" y="1905318"/>
+            <a:ext cx="2526804" cy="933767"/>
           </a:xfrm>
         </p:spPr>
         <p:txBody>
@@ -1945,39 +2036,39 @@
           <a:lstStyle>
             <a:lvl1pPr marL="0" indent="0">
               <a:buNone/>
-              <a:defRPr sz="811" b="1"/>
+              <a:defRPr sz="1560" b="1"/>
             </a:lvl1pPr>
-            <a:lvl2pPr marL="154534" indent="0">
-              <a:buNone/>
-              <a:defRPr sz="676" b="1"/>
+            <a:lvl2pPr marL="297180" indent="0">
+              <a:buNone/>
+              <a:defRPr sz="1300" b="1"/>
             </a:lvl2pPr>
-            <a:lvl3pPr marL="309067" indent="0">
-              <a:buNone/>
-              <a:defRPr sz="608" b="1"/>
+            <a:lvl3pPr marL="594360" indent="0">
+              <a:buNone/>
+              <a:defRPr sz="1170" b="1"/>
             </a:lvl3pPr>
-            <a:lvl4pPr marL="463601" indent="0">
-              <a:buNone/>
-              <a:defRPr sz="541" b="1"/>
+            <a:lvl4pPr marL="891540" indent="0">
+              <a:buNone/>
+              <a:defRPr sz="1040" b="1"/>
             </a:lvl4pPr>
-            <a:lvl5pPr marL="618134" indent="0">
-              <a:buNone/>
-              <a:defRPr sz="541" b="1"/>
+            <a:lvl5pPr marL="1188720" indent="0">
+              <a:buNone/>
+              <a:defRPr sz="1040" b="1"/>
             </a:lvl5pPr>
-            <a:lvl6pPr marL="772668" indent="0">
-              <a:buNone/>
-              <a:defRPr sz="541" b="1"/>
+            <a:lvl6pPr marL="1485900" indent="0">
+              <a:buNone/>
+              <a:defRPr sz="1040" b="1"/>
             </a:lvl6pPr>
-            <a:lvl7pPr marL="927202" indent="0">
-              <a:buNone/>
-              <a:defRPr sz="541" b="1"/>
+            <a:lvl7pPr marL="1783080" indent="0">
+              <a:buNone/>
+              <a:defRPr sz="1040" b="1"/>
             </a:lvl7pPr>
-            <a:lvl8pPr marL="1081735" indent="0">
-              <a:buNone/>
-              <a:defRPr sz="541" b="1"/>
+            <a:lvl8pPr marL="2080260" indent="0">
+              <a:buNone/>
+              <a:defRPr sz="1040" b="1"/>
             </a:lvl8pPr>
-            <a:lvl9pPr marL="1236269" indent="0">
-              <a:buNone/>
-              <a:defRPr sz="541" b="1"/>
+            <a:lvl9pPr marL="2377440" indent="0">
+              <a:buNone/>
+              <a:defRPr sz="1040" b="1"/>
             </a:lvl9pPr>
           </a:lstStyle>
           <a:p>
@@ -2001,8 +2092,8 @@
         </p:nvSpPr>
         <p:spPr>
           <a:xfrm>
-            <a:off x="1564750" y="2839085"/>
-            <a:ext cx="1314019" cy="4175866"/>
+            <a:off x="3008948" y="2839085"/>
+            <a:ext cx="2526804" cy="4175866"/>
           </a:xfrm>
         </p:spPr>
         <p:txBody>
@@ -2063,7 +2154,7 @@
           <a:p>
             <a:fld id="{94060ED0-D23E-A044-9972-B94295700C82}" type="datetimeFigureOut">
               <a:rPr lang="en-US" smtClean="0"/>
-              <a:t>4/22/26</a:t>
+              <a:t>4/27/26</a:t>
             </a:fld>
             <a:endParaRPr lang="en-US"/>
           </a:p>
@@ -2114,7 +2205,7 @@
     </p:spTree>
     <p:extLst>
       <p:ext uri="{BB962C8B-B14F-4D97-AF65-F5344CB8AC3E}">
-        <p14:creationId xmlns:p14="http://schemas.microsoft.com/office/powerpoint/2010/main" val="3755242804"/>
+        <p14:creationId xmlns:p14="http://schemas.microsoft.com/office/powerpoint/2010/main" val="4124037681"/>
       </p:ext>
     </p:extLst>
   </p:cSld>
@@ -2181,7 +2272,7 @@
           <a:p>
             <a:fld id="{94060ED0-D23E-A044-9972-B94295700C82}" type="datetimeFigureOut">
               <a:rPr lang="en-US" smtClean="0"/>
-              <a:t>4/22/26</a:t>
+              <a:t>4/27/26</a:t>
             </a:fld>
             <a:endParaRPr lang="en-US"/>
           </a:p>
@@ -2232,7 +2323,7 @@
     </p:spTree>
     <p:extLst>
       <p:ext uri="{BB962C8B-B14F-4D97-AF65-F5344CB8AC3E}">
-        <p14:creationId xmlns:p14="http://schemas.microsoft.com/office/powerpoint/2010/main" val="335950588"/>
+        <p14:creationId xmlns:p14="http://schemas.microsoft.com/office/powerpoint/2010/main" val="4170104060"/>
       </p:ext>
     </p:extLst>
   </p:cSld>
@@ -2276,7 +2367,7 @@
           <a:p>
             <a:fld id="{94060ED0-D23E-A044-9972-B94295700C82}" type="datetimeFigureOut">
               <a:rPr lang="en-US" smtClean="0"/>
-              <a:t>4/22/26</a:t>
+              <a:t>4/27/26</a:t>
             </a:fld>
             <a:endParaRPr lang="en-US"/>
           </a:p>
@@ -2327,7 +2418,7 @@
     </p:spTree>
     <p:extLst>
       <p:ext uri="{BB962C8B-B14F-4D97-AF65-F5344CB8AC3E}">
-        <p14:creationId xmlns:p14="http://schemas.microsoft.com/office/powerpoint/2010/main" val="130885112"/>
+        <p14:creationId xmlns:p14="http://schemas.microsoft.com/office/powerpoint/2010/main" val="649248594"/>
       </p:ext>
     </p:extLst>
   </p:cSld>
@@ -2366,15 +2457,15 @@
         </p:nvSpPr>
         <p:spPr>
           <a:xfrm>
-            <a:off x="212899" y="518160"/>
-            <a:ext cx="996884" cy="1813560"/>
+            <a:off x="409397" y="518160"/>
+            <a:ext cx="1916966" cy="1813560"/>
           </a:xfrm>
         </p:spPr>
         <p:txBody>
           <a:bodyPr anchor="b"/>
           <a:lstStyle>
             <a:lvl1pPr>
-              <a:defRPr sz="1082"/>
+              <a:defRPr sz="2080"/>
             </a:lvl1pPr>
           </a:lstStyle>
           <a:p>
@@ -2398,39 +2489,39 @@
         </p:nvSpPr>
         <p:spPr>
           <a:xfrm>
-            <a:off x="1314020" y="1119083"/>
-            <a:ext cx="1564749" cy="5523442"/>
+            <a:off x="2526804" y="1119083"/>
+            <a:ext cx="3008948" cy="5523442"/>
           </a:xfrm>
         </p:spPr>
         <p:txBody>
           <a:bodyPr/>
           <a:lstStyle>
             <a:lvl1pPr>
-              <a:defRPr sz="1082"/>
+              <a:defRPr sz="2080"/>
             </a:lvl1pPr>
             <a:lvl2pPr>
-              <a:defRPr sz="946"/>
+              <a:defRPr sz="1820"/>
             </a:lvl2pPr>
             <a:lvl3pPr>
-              <a:defRPr sz="811"/>
+              <a:defRPr sz="1560"/>
             </a:lvl3pPr>
             <a:lvl4pPr>
-              <a:defRPr sz="676"/>
+              <a:defRPr sz="1300"/>
             </a:lvl4pPr>
             <a:lvl5pPr>
-              <a:defRPr sz="676"/>
+              <a:defRPr sz="1300"/>
             </a:lvl5pPr>
             <a:lvl6pPr>
-              <a:defRPr sz="676"/>
+              <a:defRPr sz="1300"/>
             </a:lvl6pPr>
             <a:lvl7pPr>
-              <a:defRPr sz="676"/>
+              <a:defRPr sz="1300"/>
             </a:lvl7pPr>
             <a:lvl8pPr>
-              <a:defRPr sz="676"/>
+              <a:defRPr sz="1300"/>
             </a:lvl8pPr>
             <a:lvl9pPr>
-              <a:defRPr sz="676"/>
+              <a:defRPr sz="1300"/>
             </a:lvl9pPr>
           </a:lstStyle>
           <a:p>
@@ -2483,8 +2574,8 @@
         </p:nvSpPr>
         <p:spPr>
           <a:xfrm>
-            <a:off x="212899" y="2331720"/>
-            <a:ext cx="996884" cy="4319800"/>
+            <a:off x="409397" y="2331720"/>
+            <a:ext cx="1916966" cy="4319800"/>
           </a:xfrm>
         </p:spPr>
         <p:txBody>
@@ -2492,39 +2583,39 @@
           <a:lstStyle>
             <a:lvl1pPr marL="0" indent="0">
               <a:buNone/>
-              <a:defRPr sz="541"/>
+              <a:defRPr sz="1040"/>
             </a:lvl1pPr>
-            <a:lvl2pPr marL="154534" indent="0">
-              <a:buNone/>
-              <a:defRPr sz="473"/>
+            <a:lvl2pPr marL="297180" indent="0">
+              <a:buNone/>
+              <a:defRPr sz="910"/>
             </a:lvl2pPr>
-            <a:lvl3pPr marL="309067" indent="0">
-              <a:buNone/>
-              <a:defRPr sz="406"/>
+            <a:lvl3pPr marL="594360" indent="0">
+              <a:buNone/>
+              <a:defRPr sz="780"/>
             </a:lvl3pPr>
-            <a:lvl4pPr marL="463601" indent="0">
-              <a:buNone/>
-              <a:defRPr sz="338"/>
+            <a:lvl4pPr marL="891540" indent="0">
+              <a:buNone/>
+              <a:defRPr sz="650"/>
             </a:lvl4pPr>
-            <a:lvl5pPr marL="618134" indent="0">
-              <a:buNone/>
-              <a:defRPr sz="338"/>
+            <a:lvl5pPr marL="1188720" indent="0">
+              <a:buNone/>
+              <a:defRPr sz="650"/>
             </a:lvl5pPr>
-            <a:lvl6pPr marL="772668" indent="0">
-              <a:buNone/>
-              <a:defRPr sz="338"/>
+            <a:lvl6pPr marL="1485900" indent="0">
+              <a:buNone/>
+              <a:defRPr sz="650"/>
             </a:lvl6pPr>
-            <a:lvl7pPr marL="927202" indent="0">
-              <a:buNone/>
-              <a:defRPr sz="338"/>
+            <a:lvl7pPr marL="1783080" indent="0">
+              <a:buNone/>
+              <a:defRPr sz="650"/>
             </a:lvl7pPr>
-            <a:lvl8pPr marL="1081735" indent="0">
-              <a:buNone/>
-              <a:defRPr sz="338"/>
+            <a:lvl8pPr marL="2080260" indent="0">
+              <a:buNone/>
+              <a:defRPr sz="650"/>
             </a:lvl8pPr>
-            <a:lvl9pPr marL="1236269" indent="0">
-              <a:buNone/>
-              <a:defRPr sz="338"/>
+            <a:lvl9pPr marL="2377440" indent="0">
+              <a:buNone/>
+              <a:defRPr sz="650"/>
             </a:lvl9pPr>
           </a:lstStyle>
           <a:p>
@@ -2553,7 +2644,7 @@
           <a:p>
             <a:fld id="{94060ED0-D23E-A044-9972-B94295700C82}" type="datetimeFigureOut">
               <a:rPr lang="en-US" smtClean="0"/>
-              <a:t>4/22/26</a:t>
+              <a:t>4/27/26</a:t>
             </a:fld>
             <a:endParaRPr lang="en-US"/>
           </a:p>
@@ -2604,7 +2695,7 @@
     </p:spTree>
     <p:extLst>
       <p:ext uri="{BB962C8B-B14F-4D97-AF65-F5344CB8AC3E}">
-        <p14:creationId xmlns:p14="http://schemas.microsoft.com/office/powerpoint/2010/main" val="3698416623"/>
+        <p14:creationId xmlns:p14="http://schemas.microsoft.com/office/powerpoint/2010/main" val="294714024"/>
       </p:ext>
     </p:extLst>
   </p:cSld>
@@ -2643,15 +2734,15 @@
         </p:nvSpPr>
         <p:spPr>
           <a:xfrm>
-            <a:off x="212899" y="518160"/>
-            <a:ext cx="996884" cy="1813560"/>
+            <a:off x="409397" y="518160"/>
+            <a:ext cx="1916966" cy="1813560"/>
           </a:xfrm>
         </p:spPr>
         <p:txBody>
           <a:bodyPr anchor="b"/>
           <a:lstStyle>
             <a:lvl1pPr>
-              <a:defRPr sz="1082"/>
+              <a:defRPr sz="2080"/>
             </a:lvl1pPr>
           </a:lstStyle>
           <a:p>
@@ -2675,8 +2766,8 @@
         </p:nvSpPr>
         <p:spPr>
           <a:xfrm>
-            <a:off x="1314020" y="1119083"/>
-            <a:ext cx="1564749" cy="5523442"/>
+            <a:off x="2526804" y="1119083"/>
+            <a:ext cx="3008948" cy="5523442"/>
           </a:xfrm>
         </p:spPr>
         <p:txBody>
@@ -2684,39 +2775,39 @@
           <a:lstStyle>
             <a:lvl1pPr marL="0" indent="0">
               <a:buNone/>
-              <a:defRPr sz="1082"/>
+              <a:defRPr sz="2080"/>
             </a:lvl1pPr>
-            <a:lvl2pPr marL="154534" indent="0">
-              <a:buNone/>
-              <a:defRPr sz="946"/>
+            <a:lvl2pPr marL="297180" indent="0">
+              <a:buNone/>
+              <a:defRPr sz="1820"/>
             </a:lvl2pPr>
-            <a:lvl3pPr marL="309067" indent="0">
-              <a:buNone/>
-              <a:defRPr sz="811"/>
+            <a:lvl3pPr marL="594360" indent="0">
+              <a:buNone/>
+              <a:defRPr sz="1560"/>
             </a:lvl3pPr>
-            <a:lvl4pPr marL="463601" indent="0">
-              <a:buNone/>
-              <a:defRPr sz="676"/>
+            <a:lvl4pPr marL="891540" indent="0">
+              <a:buNone/>
+              <a:defRPr sz="1300"/>
             </a:lvl4pPr>
-            <a:lvl5pPr marL="618134" indent="0">
-              <a:buNone/>
-              <a:defRPr sz="676"/>
+            <a:lvl5pPr marL="1188720" indent="0">
+              <a:buNone/>
+              <a:defRPr sz="1300"/>
             </a:lvl5pPr>
-            <a:lvl6pPr marL="772668" indent="0">
-              <a:buNone/>
-              <a:defRPr sz="676"/>
+            <a:lvl6pPr marL="1485900" indent="0">
+              <a:buNone/>
+              <a:defRPr sz="1300"/>
             </a:lvl6pPr>
-            <a:lvl7pPr marL="927202" indent="0">
-              <a:buNone/>
-              <a:defRPr sz="676"/>
+            <a:lvl7pPr marL="1783080" indent="0">
+              <a:buNone/>
+              <a:defRPr sz="1300"/>
             </a:lvl7pPr>
-            <a:lvl8pPr marL="1081735" indent="0">
-              <a:buNone/>
-              <a:defRPr sz="676"/>
+            <a:lvl8pPr marL="2080260" indent="0">
+              <a:buNone/>
+              <a:defRPr sz="1300"/>
             </a:lvl8pPr>
-            <a:lvl9pPr marL="1236269" indent="0">
-              <a:buNone/>
-              <a:defRPr sz="676"/>
+            <a:lvl9pPr marL="2377440" indent="0">
+              <a:buNone/>
+              <a:defRPr sz="1300"/>
             </a:lvl9pPr>
           </a:lstStyle>
           <a:p>
@@ -2740,8 +2831,8 @@
         </p:nvSpPr>
         <p:spPr>
           <a:xfrm>
-            <a:off x="212899" y="2331720"/>
-            <a:ext cx="996884" cy="4319800"/>
+            <a:off x="409397" y="2331720"/>
+            <a:ext cx="1916966" cy="4319800"/>
           </a:xfrm>
         </p:spPr>
         <p:txBody>
@@ -2749,39 +2840,39 @@
           <a:lstStyle>
             <a:lvl1pPr marL="0" indent="0">
               <a:buNone/>
-              <a:defRPr sz="541"/>
+              <a:defRPr sz="1040"/>
             </a:lvl1pPr>
-            <a:lvl2pPr marL="154534" indent="0">
-              <a:buNone/>
-              <a:defRPr sz="473"/>
+            <a:lvl2pPr marL="297180" indent="0">
+              <a:buNone/>
+              <a:defRPr sz="910"/>
             </a:lvl2pPr>
-            <a:lvl3pPr marL="309067" indent="0">
-              <a:buNone/>
-              <a:defRPr sz="406"/>
+            <a:lvl3pPr marL="594360" indent="0">
+              <a:buNone/>
+              <a:defRPr sz="780"/>
             </a:lvl3pPr>
-            <a:lvl4pPr marL="463601" indent="0">
-              <a:buNone/>
-              <a:defRPr sz="338"/>
+            <a:lvl4pPr marL="891540" indent="0">
+              <a:buNone/>
+              <a:defRPr sz="650"/>
             </a:lvl4pPr>
-            <a:lvl5pPr marL="618134" indent="0">
-              <a:buNone/>
-              <a:defRPr sz="338"/>
+            <a:lvl5pPr marL="1188720" indent="0">
+              <a:buNone/>
+              <a:defRPr sz="650"/>
             </a:lvl5pPr>
-            <a:lvl6pPr marL="772668" indent="0">
-              <a:buNone/>
-              <a:defRPr sz="338"/>
+            <a:lvl6pPr marL="1485900" indent="0">
+              <a:buNone/>
+              <a:defRPr sz="650"/>
             </a:lvl6pPr>
-            <a:lvl7pPr marL="927202" indent="0">
-              <a:buNone/>
-              <a:defRPr sz="338"/>
+            <a:lvl7pPr marL="1783080" indent="0">
+              <a:buNone/>
+              <a:defRPr sz="650"/>
             </a:lvl7pPr>
-            <a:lvl8pPr marL="1081735" indent="0">
-              <a:buNone/>
-              <a:defRPr sz="338"/>
+            <a:lvl8pPr marL="2080260" indent="0">
+              <a:buNone/>
+              <a:defRPr sz="650"/>
             </a:lvl8pPr>
-            <a:lvl9pPr marL="1236269" indent="0">
-              <a:buNone/>
-              <a:defRPr sz="338"/>
+            <a:lvl9pPr marL="2377440" indent="0">
+              <a:buNone/>
+              <a:defRPr sz="650"/>
             </a:lvl9pPr>
           </a:lstStyle>
           <a:p>
@@ -2810,7 +2901,7 @@
           <a:p>
             <a:fld id="{94060ED0-D23E-A044-9972-B94295700C82}" type="datetimeFigureOut">
               <a:rPr lang="en-US" smtClean="0"/>
-              <a:t>4/22/26</a:t>
+              <a:t>4/27/26</a:t>
             </a:fld>
             <a:endParaRPr lang="en-US"/>
           </a:p>
@@ -2861,7 +2952,7 @@
     </p:spTree>
     <p:extLst>
       <p:ext uri="{BB962C8B-B14F-4D97-AF65-F5344CB8AC3E}">
-        <p14:creationId xmlns:p14="http://schemas.microsoft.com/office/powerpoint/2010/main" val="135199959"/>
+        <p14:creationId xmlns:p14="http://schemas.microsoft.com/office/powerpoint/2010/main" val="144985227"/>
       </p:ext>
     </p:extLst>
   </p:cSld>
@@ -2905,8 +2996,8 @@
         </p:nvSpPr>
         <p:spPr>
           <a:xfrm>
-            <a:off x="212497" y="413810"/>
-            <a:ext cx="2665869" cy="1502305"/>
+            <a:off x="408623" y="413810"/>
+            <a:ext cx="5126355" cy="1502305"/>
           </a:xfrm>
           <a:prstGeom prst="rect">
             <a:avLst/>
@@ -2938,8 +3029,8 @@
         </p:nvSpPr>
         <p:spPr>
           <a:xfrm>
-            <a:off x="212497" y="2069042"/>
-            <a:ext cx="2665869" cy="4931516"/>
+            <a:off x="408623" y="2069042"/>
+            <a:ext cx="5126355" cy="4931516"/>
           </a:xfrm>
           <a:prstGeom prst="rect">
             <a:avLst/>
@@ -3000,8 +3091,8 @@
         </p:nvSpPr>
         <p:spPr>
           <a:xfrm>
-            <a:off x="212497" y="7203865"/>
-            <a:ext cx="695444" cy="413808"/>
+            <a:off x="408622" y="7203865"/>
+            <a:ext cx="1337310" cy="413808"/>
           </a:xfrm>
           <a:prstGeom prst="rect">
             <a:avLst/>
@@ -3011,7 +3102,7 @@
           <a:bodyPr vert="horz" lIns="91440" tIns="45720" rIns="91440" bIns="45720" rtlCol="0" anchor="ctr"/>
           <a:lstStyle>
             <a:lvl1pPr algn="l">
-              <a:defRPr sz="406">
+              <a:defRPr sz="780">
                 <a:solidFill>
                   <a:schemeClr val="tx1">
                     <a:tint val="82000"/>
@@ -3023,7 +3114,7 @@
           <a:p>
             <a:fld id="{94060ED0-D23E-A044-9972-B94295700C82}" type="datetimeFigureOut">
               <a:rPr lang="en-US" smtClean="0"/>
-              <a:t>4/22/26</a:t>
+              <a:t>4/27/26</a:t>
             </a:fld>
             <a:endParaRPr lang="en-US"/>
           </a:p>
@@ -3041,8 +3132,8 @@
         </p:nvSpPr>
         <p:spPr>
           <a:xfrm>
-            <a:off x="1023849" y="7203865"/>
-            <a:ext cx="1043166" cy="413808"/>
+            <a:off x="1968818" y="7203865"/>
+            <a:ext cx="2005965" cy="413808"/>
           </a:xfrm>
           <a:prstGeom prst="rect">
             <a:avLst/>
@@ -3052,7 +3143,7 @@
           <a:bodyPr vert="horz" lIns="91440" tIns="45720" rIns="91440" bIns="45720" rtlCol="0" anchor="ctr"/>
           <a:lstStyle>
             <a:lvl1pPr algn="ctr">
-              <a:defRPr sz="406">
+              <a:defRPr sz="780">
                 <a:solidFill>
                   <a:schemeClr val="tx1">
                     <a:tint val="82000"/>
@@ -3078,8 +3169,8 @@
         </p:nvSpPr>
         <p:spPr>
           <a:xfrm>
-            <a:off x="2182922" y="7203865"/>
-            <a:ext cx="695444" cy="413808"/>
+            <a:off x="4197668" y="7203865"/>
+            <a:ext cx="1337310" cy="413808"/>
           </a:xfrm>
           <a:prstGeom prst="rect">
             <a:avLst/>
@@ -3089,7 +3180,7 @@
           <a:bodyPr vert="horz" lIns="91440" tIns="45720" rIns="91440" bIns="45720" rtlCol="0" anchor="ctr"/>
           <a:lstStyle>
             <a:lvl1pPr algn="r">
-              <a:defRPr sz="406">
+              <a:defRPr sz="780">
                 <a:solidFill>
                   <a:schemeClr val="tx1">
                     <a:tint val="82000"/>
@@ -3110,27 +3201,27 @@
     </p:spTree>
     <p:extLst>
       <p:ext uri="{BB962C8B-B14F-4D97-AF65-F5344CB8AC3E}">
-        <p14:creationId xmlns:p14="http://schemas.microsoft.com/office/powerpoint/2010/main" val="983719300"/>
+        <p14:creationId xmlns:p14="http://schemas.microsoft.com/office/powerpoint/2010/main" val="1086564214"/>
       </p:ext>
     </p:extLst>
   </p:cSld>
   <p:clrMap bg1="lt1" tx1="dk1" bg2="lt2" tx2="dk2" accent1="accent1" accent2="accent2" accent3="accent3" accent4="accent4" accent5="accent5" accent6="accent6" hlink="hlink" folHlink="folHlink"/>
   <p:sldLayoutIdLst>
-    <p:sldLayoutId id="2147483697" r:id="rId1"/>
-    <p:sldLayoutId id="2147483698" r:id="rId2"/>
-    <p:sldLayoutId id="2147483699" r:id="rId3"/>
-    <p:sldLayoutId id="2147483700" r:id="rId4"/>
-    <p:sldLayoutId id="2147483701" r:id="rId5"/>
-    <p:sldLayoutId id="2147483702" r:id="rId6"/>
-    <p:sldLayoutId id="2147483703" r:id="rId7"/>
-    <p:sldLayoutId id="2147483704" r:id="rId8"/>
-    <p:sldLayoutId id="2147483705" r:id="rId9"/>
-    <p:sldLayoutId id="2147483706" r:id="rId10"/>
-    <p:sldLayoutId id="2147483707" r:id="rId11"/>
+    <p:sldLayoutId id="2147483709" r:id="rId1"/>
+    <p:sldLayoutId id="2147483710" r:id="rId2"/>
+    <p:sldLayoutId id="2147483711" r:id="rId3"/>
+    <p:sldLayoutId id="2147483712" r:id="rId4"/>
+    <p:sldLayoutId id="2147483713" r:id="rId5"/>
+    <p:sldLayoutId id="2147483714" r:id="rId6"/>
+    <p:sldLayoutId id="2147483715" r:id="rId7"/>
+    <p:sldLayoutId id="2147483716" r:id="rId8"/>
+    <p:sldLayoutId id="2147483717" r:id="rId9"/>
+    <p:sldLayoutId id="2147483718" r:id="rId10"/>
+    <p:sldLayoutId id="2147483719" r:id="rId11"/>
   </p:sldLayoutIdLst>
   <p:txStyles>
     <p:titleStyle>
-      <a:lvl1pPr algn="l" defTabSz="309067" rtl="0" eaLnBrk="1" latinLnBrk="0" hangingPunct="1">
+      <a:lvl1pPr algn="l" defTabSz="594360" rtl="0" eaLnBrk="1" latinLnBrk="0" hangingPunct="1">
         <a:lnSpc>
           <a:spcPct val="90000"/>
         </a:lnSpc>
@@ -3138,7 +3229,7 @@
           <a:spcPct val="0"/>
         </a:spcBef>
         <a:buNone/>
-        <a:defRPr sz="1487" kern="1200">
+        <a:defRPr sz="2860" kern="1200">
           <a:solidFill>
             <a:schemeClr val="tx1"/>
           </a:solidFill>
@@ -3149,16 +3240,16 @@
       </a:lvl1pPr>
     </p:titleStyle>
     <p:bodyStyle>
-      <a:lvl1pPr marL="77267" indent="-77267" algn="l" defTabSz="309067" rtl="0" eaLnBrk="1" latinLnBrk="0" hangingPunct="1">
+      <a:lvl1pPr marL="148590" indent="-148590" algn="l" defTabSz="594360" rtl="0" eaLnBrk="1" latinLnBrk="0" hangingPunct="1">
         <a:lnSpc>
           <a:spcPct val="90000"/>
         </a:lnSpc>
         <a:spcBef>
-          <a:spcPts val="338"/>
+          <a:spcPts val="650"/>
         </a:spcBef>
         <a:buFont typeface="Arial" panose="020B0604020202020204" pitchFamily="34" charset="0"/>
         <a:buChar char="•"/>
-        <a:defRPr sz="946" kern="1200">
+        <a:defRPr sz="1820" kern="1200">
           <a:solidFill>
             <a:schemeClr val="tx1"/>
           </a:solidFill>
@@ -3167,16 +3258,16 @@
           <a:cs typeface="+mn-cs"/>
         </a:defRPr>
       </a:lvl1pPr>
-      <a:lvl2pPr marL="231800" indent="-77267" algn="l" defTabSz="309067" rtl="0" eaLnBrk="1" latinLnBrk="0" hangingPunct="1">
+      <a:lvl2pPr marL="445770" indent="-148590" algn="l" defTabSz="594360" rtl="0" eaLnBrk="1" latinLnBrk="0" hangingPunct="1">
         <a:lnSpc>
           <a:spcPct val="90000"/>
         </a:lnSpc>
         <a:spcBef>
-          <a:spcPts val="169"/>
+          <a:spcPts val="325"/>
         </a:spcBef>
         <a:buFont typeface="Arial" panose="020B0604020202020204" pitchFamily="34" charset="0"/>
         <a:buChar char="•"/>
-        <a:defRPr sz="811" kern="1200">
+        <a:defRPr sz="1560" kern="1200">
           <a:solidFill>
             <a:schemeClr val="tx1"/>
           </a:solidFill>
@@ -3185,16 +3276,16 @@
           <a:cs typeface="+mn-cs"/>
         </a:defRPr>
       </a:lvl2pPr>
-      <a:lvl3pPr marL="386334" indent="-77267" algn="l" defTabSz="309067" rtl="0" eaLnBrk="1" latinLnBrk="0" hangingPunct="1">
+      <a:lvl3pPr marL="742950" indent="-148590" algn="l" defTabSz="594360" rtl="0" eaLnBrk="1" latinLnBrk="0" hangingPunct="1">
         <a:lnSpc>
           <a:spcPct val="90000"/>
         </a:lnSpc>
         <a:spcBef>
-          <a:spcPts val="169"/>
+          <a:spcPts val="325"/>
         </a:spcBef>
         <a:buFont typeface="Arial" panose="020B0604020202020204" pitchFamily="34" charset="0"/>
         <a:buChar char="•"/>
-        <a:defRPr sz="676" kern="1200">
+        <a:defRPr sz="1300" kern="1200">
           <a:solidFill>
             <a:schemeClr val="tx1"/>
           </a:solidFill>
@@ -3203,16 +3294,16 @@
           <a:cs typeface="+mn-cs"/>
         </a:defRPr>
       </a:lvl3pPr>
-      <a:lvl4pPr marL="540868" indent="-77267" algn="l" defTabSz="309067" rtl="0" eaLnBrk="1" latinLnBrk="0" hangingPunct="1">
+      <a:lvl4pPr marL="1040130" indent="-148590" algn="l" defTabSz="594360" rtl="0" eaLnBrk="1" latinLnBrk="0" hangingPunct="1">
         <a:lnSpc>
           <a:spcPct val="90000"/>
         </a:lnSpc>
         <a:spcBef>
-          <a:spcPts val="169"/>
+          <a:spcPts val="325"/>
         </a:spcBef>
         <a:buFont typeface="Arial" panose="020B0604020202020204" pitchFamily="34" charset="0"/>
         <a:buChar char="•"/>
-        <a:defRPr sz="608" kern="1200">
+        <a:defRPr sz="1170" kern="1200">
           <a:solidFill>
             <a:schemeClr val="tx1"/>
           </a:solidFill>
@@ -3221,16 +3312,16 @@
           <a:cs typeface="+mn-cs"/>
         </a:defRPr>
       </a:lvl4pPr>
-      <a:lvl5pPr marL="695401" indent="-77267" algn="l" defTabSz="309067" rtl="0" eaLnBrk="1" latinLnBrk="0" hangingPunct="1">
+      <a:lvl5pPr marL="1337310" indent="-148590" algn="l" defTabSz="594360" rtl="0" eaLnBrk="1" latinLnBrk="0" hangingPunct="1">
         <a:lnSpc>
           <a:spcPct val="90000"/>
         </a:lnSpc>
         <a:spcBef>
-          <a:spcPts val="169"/>
+          <a:spcPts val="325"/>
         </a:spcBef>
         <a:buFont typeface="Arial" panose="020B0604020202020204" pitchFamily="34" charset="0"/>
         <a:buChar char="•"/>
-        <a:defRPr sz="608" kern="1200">
+        <a:defRPr sz="1170" kern="1200">
           <a:solidFill>
             <a:schemeClr val="tx1"/>
           </a:solidFill>
@@ -3239,16 +3330,16 @@
           <a:cs typeface="+mn-cs"/>
         </a:defRPr>
       </a:lvl5pPr>
-      <a:lvl6pPr marL="849935" indent="-77267" algn="l" defTabSz="309067" rtl="0" eaLnBrk="1" latinLnBrk="0" hangingPunct="1">
+      <a:lvl6pPr marL="1634490" indent="-148590" algn="l" defTabSz="594360" rtl="0" eaLnBrk="1" latinLnBrk="0" hangingPunct="1">
         <a:lnSpc>
           <a:spcPct val="90000"/>
         </a:lnSpc>
         <a:spcBef>
-          <a:spcPts val="169"/>
+          <a:spcPts val="325"/>
         </a:spcBef>
         <a:buFont typeface="Arial" panose="020B0604020202020204" pitchFamily="34" charset="0"/>
         <a:buChar char="•"/>
-        <a:defRPr sz="608" kern="1200">
+        <a:defRPr sz="1170" kern="1200">
           <a:solidFill>
             <a:schemeClr val="tx1"/>
           </a:solidFill>
@@ -3257,16 +3348,16 @@
           <a:cs typeface="+mn-cs"/>
         </a:defRPr>
       </a:lvl6pPr>
-      <a:lvl7pPr marL="1004468" indent="-77267" algn="l" defTabSz="309067" rtl="0" eaLnBrk="1" latinLnBrk="0" hangingPunct="1">
+      <a:lvl7pPr marL="1931670" indent="-148590" algn="l" defTabSz="594360" rtl="0" eaLnBrk="1" latinLnBrk="0" hangingPunct="1">
         <a:lnSpc>
           <a:spcPct val="90000"/>
         </a:lnSpc>
         <a:spcBef>
-          <a:spcPts val="169"/>
+          <a:spcPts val="325"/>
         </a:spcBef>
         <a:buFont typeface="Arial" panose="020B0604020202020204" pitchFamily="34" charset="0"/>
         <a:buChar char="•"/>
-        <a:defRPr sz="608" kern="1200">
+        <a:defRPr sz="1170" kern="1200">
           <a:solidFill>
             <a:schemeClr val="tx1"/>
           </a:solidFill>
@@ -3275,16 +3366,16 @@
           <a:cs typeface="+mn-cs"/>
         </a:defRPr>
       </a:lvl7pPr>
-      <a:lvl8pPr marL="1159002" indent="-77267" algn="l" defTabSz="309067" rtl="0" eaLnBrk="1" latinLnBrk="0" hangingPunct="1">
+      <a:lvl8pPr marL="2228850" indent="-148590" algn="l" defTabSz="594360" rtl="0" eaLnBrk="1" latinLnBrk="0" hangingPunct="1">
         <a:lnSpc>
           <a:spcPct val="90000"/>
         </a:lnSpc>
         <a:spcBef>
-          <a:spcPts val="169"/>
+          <a:spcPts val="325"/>
         </a:spcBef>
         <a:buFont typeface="Arial" panose="020B0604020202020204" pitchFamily="34" charset="0"/>
         <a:buChar char="•"/>
-        <a:defRPr sz="608" kern="1200">
+        <a:defRPr sz="1170" kern="1200">
           <a:solidFill>
             <a:schemeClr val="tx1"/>
           </a:solidFill>
@@ -3293,16 +3384,16 @@
           <a:cs typeface="+mn-cs"/>
         </a:defRPr>
       </a:lvl8pPr>
-      <a:lvl9pPr marL="1313536" indent="-77267" algn="l" defTabSz="309067" rtl="0" eaLnBrk="1" latinLnBrk="0" hangingPunct="1">
+      <a:lvl9pPr marL="2526030" indent="-148590" algn="l" defTabSz="594360" rtl="0" eaLnBrk="1" latinLnBrk="0" hangingPunct="1">
         <a:lnSpc>
           <a:spcPct val="90000"/>
         </a:lnSpc>
         <a:spcBef>
-          <a:spcPts val="169"/>
+          <a:spcPts val="325"/>
         </a:spcBef>
         <a:buFont typeface="Arial" panose="020B0604020202020204" pitchFamily="34" charset="0"/>
         <a:buChar char="•"/>
-        <a:defRPr sz="608" kern="1200">
+        <a:defRPr sz="1170" kern="1200">
           <a:solidFill>
             <a:schemeClr val="tx1"/>
           </a:solidFill>
@@ -3316,8 +3407,8 @@
       <a:defPPr>
         <a:defRPr lang="en-US"/>
       </a:defPPr>
-      <a:lvl1pPr marL="0" algn="l" defTabSz="309067" rtl="0" eaLnBrk="1" latinLnBrk="0" hangingPunct="1">
-        <a:defRPr sz="608" kern="1200">
+      <a:lvl1pPr marL="0" algn="l" defTabSz="594360" rtl="0" eaLnBrk="1" latinLnBrk="0" hangingPunct="1">
+        <a:defRPr sz="1170" kern="1200">
           <a:solidFill>
             <a:schemeClr val="tx1"/>
           </a:solidFill>
@@ -3326,8 +3417,8 @@
           <a:cs typeface="+mn-cs"/>
         </a:defRPr>
       </a:lvl1pPr>
-      <a:lvl2pPr marL="154534" algn="l" defTabSz="309067" rtl="0" eaLnBrk="1" latinLnBrk="0" hangingPunct="1">
-        <a:defRPr sz="608" kern="1200">
+      <a:lvl2pPr marL="297180" algn="l" defTabSz="594360" rtl="0" eaLnBrk="1" latinLnBrk="0" hangingPunct="1">
+        <a:defRPr sz="1170" kern="1200">
           <a:solidFill>
             <a:schemeClr val="tx1"/>
           </a:solidFill>
@@ -3336,8 +3427,8 @@
           <a:cs typeface="+mn-cs"/>
         </a:defRPr>
       </a:lvl2pPr>
-      <a:lvl3pPr marL="309067" algn="l" defTabSz="309067" rtl="0" eaLnBrk="1" latinLnBrk="0" hangingPunct="1">
-        <a:defRPr sz="608" kern="1200">
+      <a:lvl3pPr marL="594360" algn="l" defTabSz="594360" rtl="0" eaLnBrk="1" latinLnBrk="0" hangingPunct="1">
+        <a:defRPr sz="1170" kern="1200">
           <a:solidFill>
             <a:schemeClr val="tx1"/>
           </a:solidFill>
@@ -3346,8 +3437,8 @@
           <a:cs typeface="+mn-cs"/>
         </a:defRPr>
       </a:lvl3pPr>
-      <a:lvl4pPr marL="463601" algn="l" defTabSz="309067" rtl="0" eaLnBrk="1" latinLnBrk="0" hangingPunct="1">
-        <a:defRPr sz="608" kern="1200">
+      <a:lvl4pPr marL="891540" algn="l" defTabSz="594360" rtl="0" eaLnBrk="1" latinLnBrk="0" hangingPunct="1">
+        <a:defRPr sz="1170" kern="1200">
           <a:solidFill>
             <a:schemeClr val="tx1"/>
           </a:solidFill>
@@ -3356,8 +3447,8 @@
           <a:cs typeface="+mn-cs"/>
         </a:defRPr>
       </a:lvl4pPr>
-      <a:lvl5pPr marL="618134" algn="l" defTabSz="309067" rtl="0" eaLnBrk="1" latinLnBrk="0" hangingPunct="1">
-        <a:defRPr sz="608" kern="1200">
+      <a:lvl5pPr marL="1188720" algn="l" defTabSz="594360" rtl="0" eaLnBrk="1" latinLnBrk="0" hangingPunct="1">
+        <a:defRPr sz="1170" kern="1200">
           <a:solidFill>
             <a:schemeClr val="tx1"/>
           </a:solidFill>
@@ -3366,8 +3457,8 @@
           <a:cs typeface="+mn-cs"/>
         </a:defRPr>
       </a:lvl5pPr>
-      <a:lvl6pPr marL="772668" algn="l" defTabSz="309067" rtl="0" eaLnBrk="1" latinLnBrk="0" hangingPunct="1">
-        <a:defRPr sz="608" kern="1200">
+      <a:lvl6pPr marL="1485900" algn="l" defTabSz="594360" rtl="0" eaLnBrk="1" latinLnBrk="0" hangingPunct="1">
+        <a:defRPr sz="1170" kern="1200">
           <a:solidFill>
             <a:schemeClr val="tx1"/>
           </a:solidFill>
@@ -3376,8 +3467,8 @@
           <a:cs typeface="+mn-cs"/>
         </a:defRPr>
       </a:lvl6pPr>
-      <a:lvl7pPr marL="927202" algn="l" defTabSz="309067" rtl="0" eaLnBrk="1" latinLnBrk="0" hangingPunct="1">
-        <a:defRPr sz="608" kern="1200">
+      <a:lvl7pPr marL="1783080" algn="l" defTabSz="594360" rtl="0" eaLnBrk="1" latinLnBrk="0" hangingPunct="1">
+        <a:defRPr sz="1170" kern="1200">
           <a:solidFill>
             <a:schemeClr val="tx1"/>
           </a:solidFill>
@@ -3386,8 +3477,8 @@
           <a:cs typeface="+mn-cs"/>
         </a:defRPr>
       </a:lvl7pPr>
-      <a:lvl8pPr marL="1081735" algn="l" defTabSz="309067" rtl="0" eaLnBrk="1" latinLnBrk="0" hangingPunct="1">
-        <a:defRPr sz="608" kern="1200">
+      <a:lvl8pPr marL="2080260" algn="l" defTabSz="594360" rtl="0" eaLnBrk="1" latinLnBrk="0" hangingPunct="1">
+        <a:defRPr sz="1170" kern="1200">
           <a:solidFill>
             <a:schemeClr val="tx1"/>
           </a:solidFill>
@@ -3396,8 +3487,8 @@
           <a:cs typeface="+mn-cs"/>
         </a:defRPr>
       </a:lvl8pPr>
-      <a:lvl9pPr marL="1236269" algn="l" defTabSz="309067" rtl="0" eaLnBrk="1" latinLnBrk="0" hangingPunct="1">
-        <a:defRPr sz="608" kern="1200">
+      <a:lvl9pPr marL="2377440" algn="l" defTabSz="594360" rtl="0" eaLnBrk="1" latinLnBrk="0" hangingPunct="1">
+        <a:defRPr sz="1170" kern="1200">
           <a:solidFill>
             <a:schemeClr val="tx1"/>
           </a:solidFill>
@@ -3442,7 +3533,7 @@
         </p:nvGrpSpPr>
         <p:grpSpPr>
           <a:xfrm>
-            <a:off x="34612" y="32033"/>
+            <a:off x="1460982" y="32033"/>
             <a:ext cx="3056251" cy="914400"/>
             <a:chOff x="34612" y="1371600"/>
             <a:chExt cx="3056251" cy="914400"/>
@@ -3880,14 +3971,14 @@
           <p:nvPr/>
         </p:nvPicPr>
         <p:blipFill>
-          <a:blip r:embed="rId3"/>
+          <a:blip/>
           <a:stretch>
             <a:fillRect/>
           </a:stretch>
         </p:blipFill>
         <p:spPr>
           <a:xfrm>
-            <a:off x="10661" y="4206710"/>
+            <a:off x="1437031" y="4206710"/>
             <a:ext cx="3094293" cy="3565690"/>
           </a:xfrm>
           <a:prstGeom prst="rect">
@@ -3910,14 +4001,14 @@
           <p:nvPr/>
         </p:nvPicPr>
         <p:blipFill>
-          <a:blip r:embed="rId4"/>
+          <a:blip/>
           <a:stretch>
             <a:fillRect/>
           </a:stretch>
         </p:blipFill>
         <p:spPr>
           <a:xfrm>
-            <a:off x="0" y="2790578"/>
+            <a:off x="1426370" y="2790578"/>
             <a:ext cx="3090863" cy="1416132"/>
           </a:xfrm>
           <a:prstGeom prst="rect">
@@ -3940,14 +4031,14 @@
           <p:nvPr/>
         </p:nvPicPr>
         <p:blipFill>
-          <a:blip r:embed="rId5"/>
+          <a:blip/>
           <a:stretch>
             <a:fillRect/>
           </a:stretch>
         </p:blipFill>
         <p:spPr>
           <a:xfrm>
-            <a:off x="10661" y="931136"/>
+            <a:off x="1437031" y="931137"/>
             <a:ext cx="3090863" cy="1859443"/>
           </a:xfrm>
           <a:prstGeom prst="rect">
@@ -3969,7 +4060,7 @@
         </p:nvSpPr>
         <p:spPr>
           <a:xfrm>
-            <a:off x="2790220" y="-59518"/>
+            <a:off x="4216589" y="-59518"/>
             <a:ext cx="311304" cy="369332"/>
           </a:xfrm>
           <a:prstGeom prst="rect">
@@ -4004,7 +4095,7 @@
         </p:nvSpPr>
         <p:spPr>
           <a:xfrm>
-            <a:off x="2792867" y="874047"/>
+            <a:off x="4219236" y="874047"/>
             <a:ext cx="319318" cy="369332"/>
           </a:xfrm>
           <a:prstGeom prst="rect">
@@ -4039,7 +4130,7 @@
         </p:nvSpPr>
         <p:spPr>
           <a:xfrm>
-            <a:off x="2760884" y="2743022"/>
+            <a:off x="4187253" y="2743022"/>
             <a:ext cx="311304" cy="369332"/>
           </a:xfrm>
           <a:prstGeom prst="rect">
@@ -4074,7 +4165,7 @@
         </p:nvSpPr>
         <p:spPr>
           <a:xfrm>
-            <a:off x="2758579" y="4105556"/>
+            <a:off x="4184948" y="4105556"/>
             <a:ext cx="319318" cy="369332"/>
           </a:xfrm>
           <a:prstGeom prst="rect">
@@ -4099,6 +4190,1305 @@
     <p:extLst>
       <p:ext uri="{BB962C8B-B14F-4D97-AF65-F5344CB8AC3E}">
         <p14:creationId xmlns:p14="http://schemas.microsoft.com/office/powerpoint/2010/main" val="1806791837"/>
+      </p:ext>
+    </p:extLst>
+  </p:cSld>
+  <p:clrMapOvr>
+    <a:masterClrMapping/>
+  </p:clrMapOvr>
+</p:sld>
+</file>
+
+<file path=ppt/slides/slide2.xml><?xml version="1.0" encoding="utf-8"?>
+<p:sld xmlns:a="http://schemas.openxmlformats.org/drawingml/2006/main" xmlns:r="http://schemas.openxmlformats.org/officeDocument/2006/relationships" xmlns:p="http://schemas.openxmlformats.org/presentationml/2006/main">
+  <p:cSld>
+    <p:spTree>
+      <p:nvGrpSpPr>
+        <p:cNvPr id="1" name=""/>
+        <p:cNvGrpSpPr/>
+        <p:nvPr/>
+      </p:nvGrpSpPr>
+      <p:grpSpPr>
+        <a:xfrm>
+          <a:off x="0" y="0"/>
+          <a:ext cx="0" cy="0"/>
+          <a:chOff x="0" y="0"/>
+          <a:chExt cx="0" cy="0"/>
+        </a:xfrm>
+      </p:grpSpPr>
+      <p:pic>
+        <p:nvPicPr>
+          <p:cNvPr id="13" name="Picture 12">
+            <a:extLst>
+              <a:ext uri="{FF2B5EF4-FFF2-40B4-BE49-F238E27FC236}">
+                <a16:creationId xmlns:a16="http://schemas.microsoft.com/office/drawing/2014/main" id="{EEA21564-77F4-DFEB-B5C7-CED28422374E}"/>
+              </a:ext>
+            </a:extLst>
+          </p:cNvPr>
+          <p:cNvPicPr>
+            <a:picLocks noChangeAspect="1"/>
+          </p:cNvPicPr>
+          <p:nvPr/>
+        </p:nvPicPr>
+        <p:blipFill>
+          <a:blip/>
+          <a:stretch>
+            <a:fillRect/>
+          </a:stretch>
+        </p:blipFill>
+        <p:spPr>
+          <a:xfrm>
+            <a:off x="2467462" y="0"/>
+            <a:ext cx="2449395" cy="2822545"/>
+          </a:xfrm>
+          <a:prstGeom prst="rect">
+            <a:avLst/>
+          </a:prstGeom>
+        </p:spPr>
+      </p:pic>
+      <p:pic>
+        <p:nvPicPr>
+          <p:cNvPr id="15" name="Picture 14">
+            <a:extLst>
+              <a:ext uri="{FF2B5EF4-FFF2-40B4-BE49-F238E27FC236}">
+                <a16:creationId xmlns:a16="http://schemas.microsoft.com/office/drawing/2014/main" id="{915F7B7D-A828-1D4C-9F0E-AF0126B61821}"/>
+              </a:ext>
+            </a:extLst>
+          </p:cNvPr>
+          <p:cNvPicPr>
+            <a:picLocks noChangeAspect="1"/>
+          </p:cNvPicPr>
+          <p:nvPr/>
+        </p:nvPicPr>
+        <p:blipFill>
+          <a:blip/>
+          <a:stretch>
+            <a:fillRect/>
+          </a:stretch>
+        </p:blipFill>
+        <p:spPr>
+          <a:xfrm>
+            <a:off x="0" y="501320"/>
+            <a:ext cx="2452526" cy="1241756"/>
+          </a:xfrm>
+          <a:prstGeom prst="rect">
+            <a:avLst/>
+          </a:prstGeom>
+        </p:spPr>
+      </p:pic>
+      <p:grpSp>
+        <p:nvGrpSpPr>
+          <p:cNvPr id="2" name="Group 1">
+            <a:extLst>
+              <a:ext uri="{FF2B5EF4-FFF2-40B4-BE49-F238E27FC236}">
+                <a16:creationId xmlns:a16="http://schemas.microsoft.com/office/drawing/2014/main" id="{68667925-0098-3ED4-654C-C155189693A4}"/>
+              </a:ext>
+            </a:extLst>
+          </p:cNvPr>
+          <p:cNvGrpSpPr/>
+          <p:nvPr/>
+        </p:nvGrpSpPr>
+        <p:grpSpPr>
+          <a:xfrm>
+            <a:off x="2" y="19933"/>
+            <a:ext cx="2478880" cy="623783"/>
+            <a:chOff x="34612" y="1371600"/>
+            <a:chExt cx="2986143" cy="1065765"/>
+          </a:xfrm>
+        </p:grpSpPr>
+        <p:sp>
+          <p:nvSpPr>
+            <p:cNvPr id="3" name="Rounded Rectangle 2">
+              <a:extLst>
+                <a:ext uri="{FF2B5EF4-FFF2-40B4-BE49-F238E27FC236}">
+                  <a16:creationId xmlns:a16="http://schemas.microsoft.com/office/drawing/2014/main" id="{FC34FA5B-0558-CF4E-2F35-E7A06B871CEB}"/>
+                </a:ext>
+              </a:extLst>
+            </p:cNvPr>
+            <p:cNvSpPr/>
+            <p:nvPr/>
+          </p:nvSpPr>
+          <p:spPr>
+            <a:xfrm>
+              <a:off x="985895" y="1524009"/>
+              <a:ext cx="559536" cy="609585"/>
+            </a:xfrm>
+            <a:prstGeom prst="roundRect">
+              <a:avLst/>
+            </a:prstGeom>
+          </p:spPr>
+          <p:style>
+            <a:lnRef idx="2">
+              <a:schemeClr val="accent4">
+                <a:shade val="15000"/>
+              </a:schemeClr>
+            </a:lnRef>
+            <a:fillRef idx="1">
+              <a:schemeClr val="accent4"/>
+            </a:fillRef>
+            <a:effectRef idx="0">
+              <a:schemeClr val="accent4"/>
+            </a:effectRef>
+            <a:fontRef idx="minor">
+              <a:schemeClr val="lt1"/>
+            </a:fontRef>
+          </p:style>
+          <p:txBody>
+            <a:bodyPr rtlCol="0" anchor="ctr"/>
+            <a:lstStyle/>
+            <a:p>
+              <a:pPr algn="ctr"/>
+              <a:r>
+                <a:rPr lang="en-US" sz="800" dirty="0"/>
+                <a:t>MLP</a:t>
+              </a:r>
+            </a:p>
+          </p:txBody>
+        </p:sp>
+        <p:sp>
+          <p:nvSpPr>
+            <p:cNvPr id="4" name="Rounded Rectangle 3">
+              <a:extLst>
+                <a:ext uri="{FF2B5EF4-FFF2-40B4-BE49-F238E27FC236}">
+                  <a16:creationId xmlns:a16="http://schemas.microsoft.com/office/drawing/2014/main" id="{5A9EE49D-056E-7788-5972-0CAEA077353E}"/>
+                </a:ext>
+              </a:extLst>
+            </p:cNvPr>
+            <p:cNvSpPr/>
+            <p:nvPr/>
+          </p:nvSpPr>
+          <p:spPr>
+            <a:xfrm>
+              <a:off x="2104969" y="1371600"/>
+              <a:ext cx="559537" cy="914400"/>
+            </a:xfrm>
+            <a:prstGeom prst="roundRect">
+              <a:avLst/>
+            </a:prstGeom>
+          </p:spPr>
+          <p:style>
+            <a:lnRef idx="2">
+              <a:schemeClr val="accent4">
+                <a:shade val="15000"/>
+              </a:schemeClr>
+            </a:lnRef>
+            <a:fillRef idx="1">
+              <a:schemeClr val="accent4"/>
+            </a:fillRef>
+            <a:effectRef idx="0">
+              <a:schemeClr val="accent4"/>
+            </a:effectRef>
+            <a:fontRef idx="minor">
+              <a:schemeClr val="lt1"/>
+            </a:fontRef>
+          </p:style>
+          <p:txBody>
+            <a:bodyPr rtlCol="0" anchor="ctr"/>
+            <a:lstStyle/>
+            <a:p>
+              <a:pPr algn="ctr"/>
+              <a:r>
+                <a:rPr lang="en-US" sz="800" dirty="0"/>
+                <a:t>1D CNN</a:t>
+              </a:r>
+            </a:p>
+          </p:txBody>
+        </p:sp>
+        <p:cxnSp>
+          <p:nvCxnSpPr>
+            <p:cNvPr id="5" name="Straight Arrow Connector 4">
+              <a:extLst>
+                <a:ext uri="{FF2B5EF4-FFF2-40B4-BE49-F238E27FC236}">
+                  <a16:creationId xmlns:a16="http://schemas.microsoft.com/office/drawing/2014/main" id="{F844C79E-5FEC-0D8E-64D2-286B26A26EA3}"/>
+                </a:ext>
+              </a:extLst>
+            </p:cNvPr>
+            <p:cNvCxnSpPr>
+              <a:cxnSpLocks/>
+            </p:cNvCxnSpPr>
+            <p:nvPr/>
+          </p:nvCxnSpPr>
+          <p:spPr>
+            <a:xfrm>
+              <a:off x="540776" y="1730118"/>
+              <a:ext cx="445121" cy="0"/>
+            </a:xfrm>
+            <a:prstGeom prst="straightConnector1">
+              <a:avLst/>
+            </a:prstGeom>
+            <a:ln w="38100">
+              <a:tailEnd type="triangle"/>
+            </a:ln>
+          </p:spPr>
+          <p:style>
+            <a:lnRef idx="2">
+              <a:schemeClr val="dk1"/>
+            </a:lnRef>
+            <a:fillRef idx="0">
+              <a:schemeClr val="dk1"/>
+            </a:fillRef>
+            <a:effectRef idx="1">
+              <a:schemeClr val="dk1"/>
+            </a:effectRef>
+            <a:fontRef idx="minor">
+              <a:schemeClr val="tx1"/>
+            </a:fontRef>
+          </p:style>
+        </p:cxnSp>
+        <p:cxnSp>
+          <p:nvCxnSpPr>
+            <p:cNvPr id="6" name="Straight Arrow Connector 5">
+              <a:extLst>
+                <a:ext uri="{FF2B5EF4-FFF2-40B4-BE49-F238E27FC236}">
+                  <a16:creationId xmlns:a16="http://schemas.microsoft.com/office/drawing/2014/main" id="{40276370-1245-E5D0-3228-2018F1564A19}"/>
+                </a:ext>
+              </a:extLst>
+            </p:cNvPr>
+            <p:cNvCxnSpPr>
+              <a:cxnSpLocks/>
+            </p:cNvCxnSpPr>
+            <p:nvPr/>
+          </p:nvCxnSpPr>
+          <p:spPr>
+            <a:xfrm>
+              <a:off x="540776" y="1939712"/>
+              <a:ext cx="445121" cy="0"/>
+            </a:xfrm>
+            <a:prstGeom prst="straightConnector1">
+              <a:avLst/>
+            </a:prstGeom>
+            <a:ln w="38100">
+              <a:tailEnd type="triangle"/>
+            </a:ln>
+          </p:spPr>
+          <p:style>
+            <a:lnRef idx="2">
+              <a:schemeClr val="dk1"/>
+            </a:lnRef>
+            <a:fillRef idx="0">
+              <a:schemeClr val="dk1"/>
+            </a:fillRef>
+            <a:effectRef idx="1">
+              <a:schemeClr val="dk1"/>
+            </a:effectRef>
+            <a:fontRef idx="minor">
+              <a:schemeClr val="tx1"/>
+            </a:fontRef>
+          </p:style>
+        </p:cxnSp>
+        <p:sp>
+          <p:nvSpPr>
+            <p:cNvPr id="7" name="TextBox 6">
+              <a:extLst>
+                <a:ext uri="{FF2B5EF4-FFF2-40B4-BE49-F238E27FC236}">
+                  <a16:creationId xmlns:a16="http://schemas.microsoft.com/office/drawing/2014/main" id="{B2F3E47D-3D39-E6E0-AC2E-0C094C34E7C1}"/>
+                </a:ext>
+              </a:extLst>
+            </p:cNvPr>
+            <p:cNvSpPr txBox="1"/>
+            <p:nvPr/>
+          </p:nvSpPr>
+          <p:spPr>
+            <a:xfrm>
+              <a:off x="34612" y="1436489"/>
+              <a:ext cx="845376" cy="551475"/>
+            </a:xfrm>
+            <a:prstGeom prst="rect">
+              <a:avLst/>
+            </a:prstGeom>
+            <a:noFill/>
+          </p:spPr>
+          <p:txBody>
+            <a:bodyPr wrap="square" rtlCol="0">
+              <a:spAutoFit/>
+            </a:bodyPr>
+            <a:lstStyle/>
+            <a:p>
+              <a:r>
+                <a:rPr lang="en-US" sz="800" dirty="0"/>
+                <a:t>Categorical inputs</a:t>
+              </a:r>
+            </a:p>
+          </p:txBody>
+        </p:sp>
+        <p:sp>
+          <p:nvSpPr>
+            <p:cNvPr id="8" name="TextBox 7">
+              <a:extLst>
+                <a:ext uri="{FF2B5EF4-FFF2-40B4-BE49-F238E27FC236}">
+                  <a16:creationId xmlns:a16="http://schemas.microsoft.com/office/drawing/2014/main" id="{65CCE49F-C8F2-C890-4C3C-676BABA8DBD6}"/>
+                </a:ext>
+              </a:extLst>
+            </p:cNvPr>
+            <p:cNvSpPr txBox="1"/>
+            <p:nvPr/>
+          </p:nvSpPr>
+          <p:spPr>
+            <a:xfrm>
+              <a:off x="34612" y="1885890"/>
+              <a:ext cx="845376" cy="551475"/>
+            </a:xfrm>
+            <a:prstGeom prst="rect">
+              <a:avLst/>
+            </a:prstGeom>
+            <a:noFill/>
+          </p:spPr>
+          <p:txBody>
+            <a:bodyPr wrap="square" rtlCol="0">
+              <a:spAutoFit/>
+            </a:bodyPr>
+            <a:lstStyle/>
+            <a:p>
+              <a:r>
+                <a:rPr lang="en-US" sz="800" dirty="0"/>
+                <a:t>Continuous inputs</a:t>
+              </a:r>
+            </a:p>
+          </p:txBody>
+        </p:sp>
+        <p:cxnSp>
+          <p:nvCxnSpPr>
+            <p:cNvPr id="9" name="Straight Arrow Connector 8">
+              <a:extLst>
+                <a:ext uri="{FF2B5EF4-FFF2-40B4-BE49-F238E27FC236}">
+                  <a16:creationId xmlns:a16="http://schemas.microsoft.com/office/drawing/2014/main" id="{167FADCF-34D5-DB5F-6224-8F28E62A6680}"/>
+                </a:ext>
+              </a:extLst>
+            </p:cNvPr>
+            <p:cNvCxnSpPr>
+              <a:cxnSpLocks/>
+              <a:stCxn id="3" idx="3"/>
+              <a:endCxn id="4" idx="1"/>
+            </p:cNvCxnSpPr>
+            <p:nvPr/>
+          </p:nvCxnSpPr>
+          <p:spPr>
+            <a:xfrm>
+              <a:off x="1545431" y="1828800"/>
+              <a:ext cx="559536" cy="0"/>
+            </a:xfrm>
+            <a:prstGeom prst="straightConnector1">
+              <a:avLst/>
+            </a:prstGeom>
+            <a:ln w="38100">
+              <a:tailEnd type="triangle"/>
+            </a:ln>
+          </p:spPr>
+          <p:style>
+            <a:lnRef idx="2">
+              <a:schemeClr val="dk1"/>
+            </a:lnRef>
+            <a:fillRef idx="0">
+              <a:schemeClr val="dk1"/>
+            </a:fillRef>
+            <a:effectRef idx="1">
+              <a:schemeClr val="dk1"/>
+            </a:effectRef>
+            <a:fontRef idx="minor">
+              <a:schemeClr val="tx1"/>
+            </a:fontRef>
+          </p:style>
+        </p:cxnSp>
+        <p:sp>
+          <p:nvSpPr>
+            <p:cNvPr id="10" name="TextBox 9">
+              <a:extLst>
+                <a:ext uri="{FF2B5EF4-FFF2-40B4-BE49-F238E27FC236}">
+                  <a16:creationId xmlns:a16="http://schemas.microsoft.com/office/drawing/2014/main" id="{D4CC4DFD-50F3-895A-CB32-2E188DF466E3}"/>
+                </a:ext>
+              </a:extLst>
+            </p:cNvPr>
+            <p:cNvSpPr txBox="1"/>
+            <p:nvPr/>
+          </p:nvSpPr>
+          <p:spPr>
+            <a:xfrm>
+              <a:off x="1502035" y="1403442"/>
+              <a:ext cx="523493" cy="723081"/>
+            </a:xfrm>
+            <a:prstGeom prst="rect">
+              <a:avLst/>
+            </a:prstGeom>
+            <a:noFill/>
+          </p:spPr>
+          <p:txBody>
+            <a:bodyPr wrap="none" rtlCol="0">
+              <a:spAutoFit/>
+            </a:bodyPr>
+            <a:lstStyle/>
+            <a:p>
+              <a:pPr>
+                <a:lnSpc>
+                  <a:spcPct val="150000"/>
+                </a:lnSpc>
+              </a:pPr>
+              <a:r>
+                <a:rPr lang="en-US" sz="800" dirty="0"/>
+                <a:t>proto-</a:t>
+              </a:r>
+              <a:br>
+                <a:rPr lang="en-US" sz="800" dirty="0"/>
+              </a:br>
+              <a:r>
+                <a:rPr lang="en-US" sz="800" dirty="0"/>
+                <a:t>spectra</a:t>
+              </a:r>
+            </a:p>
+          </p:txBody>
+        </p:sp>
+        <p:cxnSp>
+          <p:nvCxnSpPr>
+            <p:cNvPr id="11" name="Straight Arrow Connector 10">
+              <a:extLst>
+                <a:ext uri="{FF2B5EF4-FFF2-40B4-BE49-F238E27FC236}">
+                  <a16:creationId xmlns:a16="http://schemas.microsoft.com/office/drawing/2014/main" id="{807DA868-8EDD-6A74-781E-B977639BE415}"/>
+                </a:ext>
+              </a:extLst>
+            </p:cNvPr>
+            <p:cNvCxnSpPr>
+              <a:stCxn id="4" idx="3"/>
+            </p:cNvCxnSpPr>
+            <p:nvPr/>
+          </p:nvCxnSpPr>
+          <p:spPr>
+            <a:xfrm>
+              <a:off x="2664504" y="1828800"/>
+              <a:ext cx="324502" cy="0"/>
+            </a:xfrm>
+            <a:prstGeom prst="straightConnector1">
+              <a:avLst/>
+            </a:prstGeom>
+            <a:ln w="38100">
+              <a:tailEnd type="triangle"/>
+            </a:ln>
+          </p:spPr>
+          <p:style>
+            <a:lnRef idx="2">
+              <a:schemeClr val="dk1"/>
+            </a:lnRef>
+            <a:fillRef idx="0">
+              <a:schemeClr val="dk1"/>
+            </a:fillRef>
+            <a:effectRef idx="1">
+              <a:schemeClr val="dk1"/>
+            </a:effectRef>
+            <a:fontRef idx="minor">
+              <a:schemeClr val="tx1"/>
+            </a:fontRef>
+          </p:style>
+        </p:cxnSp>
+        <p:sp>
+          <p:nvSpPr>
+            <p:cNvPr id="12" name="TextBox 11">
+              <a:extLst>
+                <a:ext uri="{FF2B5EF4-FFF2-40B4-BE49-F238E27FC236}">
+                  <a16:creationId xmlns:a16="http://schemas.microsoft.com/office/drawing/2014/main" id="{C6F0470C-87D5-CA41-00CE-E3DCE7F9D9E7}"/>
+                </a:ext>
+              </a:extLst>
+            </p:cNvPr>
+            <p:cNvSpPr txBox="1"/>
+            <p:nvPr/>
+          </p:nvSpPr>
+          <p:spPr>
+            <a:xfrm>
+              <a:off x="2646511" y="1472664"/>
+              <a:ext cx="374244" cy="350940"/>
+            </a:xfrm>
+            <a:prstGeom prst="rect">
+              <a:avLst/>
+            </a:prstGeom>
+            <a:noFill/>
+          </p:spPr>
+          <p:txBody>
+            <a:bodyPr wrap="none" rtlCol="0">
+              <a:spAutoFit/>
+            </a:bodyPr>
+            <a:lstStyle/>
+            <a:p>
+              <a:r>
+                <a:rPr lang="en-US" sz="800" dirty="0"/>
+                <a:t>XRD</a:t>
+              </a:r>
+            </a:p>
+          </p:txBody>
+        </p:sp>
+      </p:grpSp>
+      <p:pic>
+        <p:nvPicPr>
+          <p:cNvPr id="14" name="Picture 13">
+            <a:extLst>
+              <a:ext uri="{FF2B5EF4-FFF2-40B4-BE49-F238E27FC236}">
+                <a16:creationId xmlns:a16="http://schemas.microsoft.com/office/drawing/2014/main" id="{016EE3EB-B83C-0D8A-1140-92265450A54B}"/>
+              </a:ext>
+            </a:extLst>
+          </p:cNvPr>
+          <p:cNvPicPr>
+            <a:picLocks noChangeAspect="1"/>
+          </p:cNvPicPr>
+          <p:nvPr/>
+        </p:nvPicPr>
+        <p:blipFill>
+          <a:blip/>
+          <a:srcRect t="4954"/>
+          <a:stretch>
+            <a:fillRect/>
+          </a:stretch>
+        </p:blipFill>
+        <p:spPr>
+          <a:xfrm>
+            <a:off x="1" y="1743077"/>
+            <a:ext cx="2478882" cy="1079478"/>
+          </a:xfrm>
+          <a:prstGeom prst="rect">
+            <a:avLst/>
+          </a:prstGeom>
+        </p:spPr>
+      </p:pic>
+    </p:spTree>
+    <p:extLst>
+      <p:ext uri="{BB962C8B-B14F-4D97-AF65-F5344CB8AC3E}">
+        <p14:creationId xmlns:p14="http://schemas.microsoft.com/office/powerpoint/2010/main" val="3691191141"/>
+      </p:ext>
+    </p:extLst>
+  </p:cSld>
+  <p:clrMapOvr>
+    <a:masterClrMapping/>
+  </p:clrMapOvr>
+</p:sld>
+</file>
+
+<file path=ppt/slides/slide3.xml><?xml version="1.0" encoding="utf-8"?>
+<p:sld xmlns:a="http://schemas.openxmlformats.org/drawingml/2006/main" xmlns:r="http://schemas.openxmlformats.org/officeDocument/2006/relationships" xmlns:p="http://schemas.openxmlformats.org/presentationml/2006/main">
+  <p:cSld>
+    <p:spTree>
+      <p:nvGrpSpPr>
+        <p:cNvPr id="1" name=""/>
+        <p:cNvGrpSpPr/>
+        <p:nvPr/>
+      </p:nvGrpSpPr>
+      <p:grpSpPr>
+        <a:xfrm>
+          <a:off x="0" y="0"/>
+          <a:ext cx="0" cy="0"/>
+          <a:chOff x="0" y="0"/>
+          <a:chExt cx="0" cy="0"/>
+        </a:xfrm>
+      </p:grpSpPr>
+      <p:pic>
+        <p:nvPicPr>
+          <p:cNvPr id="14" name="Picture 13">
+            <a:extLst>
+              <a:ext uri="{FF2B5EF4-FFF2-40B4-BE49-F238E27FC236}">
+                <a16:creationId xmlns:a16="http://schemas.microsoft.com/office/drawing/2014/main" id="{80C5FEDB-DBAF-32DB-4357-E69575B3A2A5}"/>
+              </a:ext>
+            </a:extLst>
+          </p:cNvPr>
+          <p:cNvPicPr>
+            <a:picLocks noChangeAspect="1"/>
+          </p:cNvPicPr>
+          <p:nvPr/>
+        </p:nvPicPr>
+        <p:blipFill>
+          <a:blip/>
+          <a:stretch>
+            <a:fillRect/>
+          </a:stretch>
+        </p:blipFill>
+        <p:spPr>
+          <a:xfrm>
+            <a:off x="0" y="528860"/>
+            <a:ext cx="2452526" cy="1241756"/>
+          </a:xfrm>
+          <a:prstGeom prst="rect">
+            <a:avLst/>
+          </a:prstGeom>
+        </p:spPr>
+      </p:pic>
+      <p:grpSp>
+        <p:nvGrpSpPr>
+          <p:cNvPr id="15" name="Group 14">
+            <a:extLst>
+              <a:ext uri="{FF2B5EF4-FFF2-40B4-BE49-F238E27FC236}">
+                <a16:creationId xmlns:a16="http://schemas.microsoft.com/office/drawing/2014/main" id="{27A706BA-6211-677F-7AFC-FB0DDE8F2178}"/>
+              </a:ext>
+            </a:extLst>
+          </p:cNvPr>
+          <p:cNvGrpSpPr/>
+          <p:nvPr/>
+        </p:nvGrpSpPr>
+        <p:grpSpPr>
+          <a:xfrm>
+            <a:off x="49574" y="-61946"/>
+            <a:ext cx="2467864" cy="617068"/>
+            <a:chOff x="94327" y="1231703"/>
+            <a:chExt cx="2972873" cy="1054297"/>
+          </a:xfrm>
+        </p:grpSpPr>
+        <p:sp>
+          <p:nvSpPr>
+            <p:cNvPr id="16" name="Rounded Rectangle 15">
+              <a:extLst>
+                <a:ext uri="{FF2B5EF4-FFF2-40B4-BE49-F238E27FC236}">
+                  <a16:creationId xmlns:a16="http://schemas.microsoft.com/office/drawing/2014/main" id="{092CE8CC-92D3-93B9-20AA-05EAECCB413D}"/>
+                </a:ext>
+              </a:extLst>
+            </p:cNvPr>
+            <p:cNvSpPr/>
+            <p:nvPr/>
+          </p:nvSpPr>
+          <p:spPr>
+            <a:xfrm>
+              <a:off x="1032341" y="1524010"/>
+              <a:ext cx="559536" cy="609585"/>
+            </a:xfrm>
+            <a:prstGeom prst="roundRect">
+              <a:avLst/>
+            </a:prstGeom>
+          </p:spPr>
+          <p:style>
+            <a:lnRef idx="2">
+              <a:schemeClr val="accent4">
+                <a:shade val="15000"/>
+              </a:schemeClr>
+            </a:lnRef>
+            <a:fillRef idx="1">
+              <a:schemeClr val="accent4"/>
+            </a:fillRef>
+            <a:effectRef idx="0">
+              <a:schemeClr val="accent4"/>
+            </a:effectRef>
+            <a:fontRef idx="minor">
+              <a:schemeClr val="lt1"/>
+            </a:fontRef>
+          </p:style>
+          <p:txBody>
+            <a:bodyPr rtlCol="0" anchor="ctr"/>
+            <a:lstStyle/>
+            <a:p>
+              <a:pPr algn="ctr"/>
+              <a:r>
+                <a:rPr lang="en-US" sz="800" dirty="0"/>
+                <a:t>MLP</a:t>
+              </a:r>
+            </a:p>
+          </p:txBody>
+        </p:sp>
+        <p:sp>
+          <p:nvSpPr>
+            <p:cNvPr id="17" name="Rounded Rectangle 16">
+              <a:extLst>
+                <a:ext uri="{FF2B5EF4-FFF2-40B4-BE49-F238E27FC236}">
+                  <a16:creationId xmlns:a16="http://schemas.microsoft.com/office/drawing/2014/main" id="{14E700BC-6840-42EB-D0A2-E8DB30ECEA2F}"/>
+                </a:ext>
+              </a:extLst>
+            </p:cNvPr>
+            <p:cNvSpPr/>
+            <p:nvPr/>
+          </p:nvSpPr>
+          <p:spPr>
+            <a:xfrm>
+              <a:off x="2151414" y="1371599"/>
+              <a:ext cx="559537" cy="914401"/>
+            </a:xfrm>
+            <a:prstGeom prst="roundRect">
+              <a:avLst/>
+            </a:prstGeom>
+          </p:spPr>
+          <p:style>
+            <a:lnRef idx="2">
+              <a:schemeClr val="accent4">
+                <a:shade val="15000"/>
+              </a:schemeClr>
+            </a:lnRef>
+            <a:fillRef idx="1">
+              <a:schemeClr val="accent4"/>
+            </a:fillRef>
+            <a:effectRef idx="0">
+              <a:schemeClr val="accent4"/>
+            </a:effectRef>
+            <a:fontRef idx="minor">
+              <a:schemeClr val="lt1"/>
+            </a:fontRef>
+          </p:style>
+          <p:txBody>
+            <a:bodyPr rtlCol="0" anchor="ctr"/>
+            <a:lstStyle/>
+            <a:p>
+              <a:pPr algn="ctr"/>
+              <a:r>
+                <a:rPr lang="en-US" sz="800" dirty="0"/>
+                <a:t>1D CNN</a:t>
+              </a:r>
+            </a:p>
+          </p:txBody>
+        </p:sp>
+        <p:cxnSp>
+          <p:nvCxnSpPr>
+            <p:cNvPr id="18" name="Straight Arrow Connector 17">
+              <a:extLst>
+                <a:ext uri="{FF2B5EF4-FFF2-40B4-BE49-F238E27FC236}">
+                  <a16:creationId xmlns:a16="http://schemas.microsoft.com/office/drawing/2014/main" id="{E7E4E4A0-756F-68B4-142A-33BBDC0ACEBE}"/>
+                </a:ext>
+              </a:extLst>
+            </p:cNvPr>
+            <p:cNvCxnSpPr>
+              <a:cxnSpLocks/>
+            </p:cNvCxnSpPr>
+            <p:nvPr/>
+          </p:nvCxnSpPr>
+          <p:spPr>
+            <a:xfrm>
+              <a:off x="587221" y="1730118"/>
+              <a:ext cx="445121" cy="0"/>
+            </a:xfrm>
+            <a:prstGeom prst="straightConnector1">
+              <a:avLst/>
+            </a:prstGeom>
+            <a:ln w="38100">
+              <a:tailEnd type="triangle"/>
+            </a:ln>
+          </p:spPr>
+          <p:style>
+            <a:lnRef idx="2">
+              <a:schemeClr val="dk1"/>
+            </a:lnRef>
+            <a:fillRef idx="0">
+              <a:schemeClr val="dk1"/>
+            </a:fillRef>
+            <a:effectRef idx="1">
+              <a:schemeClr val="dk1"/>
+            </a:effectRef>
+            <a:fontRef idx="minor">
+              <a:schemeClr val="tx1"/>
+            </a:fontRef>
+          </p:style>
+        </p:cxnSp>
+        <p:cxnSp>
+          <p:nvCxnSpPr>
+            <p:cNvPr id="19" name="Straight Arrow Connector 18">
+              <a:extLst>
+                <a:ext uri="{FF2B5EF4-FFF2-40B4-BE49-F238E27FC236}">
+                  <a16:creationId xmlns:a16="http://schemas.microsoft.com/office/drawing/2014/main" id="{856E5E3F-D9F8-1A75-3AD2-7E0D9E59BED2}"/>
+                </a:ext>
+              </a:extLst>
+            </p:cNvPr>
+            <p:cNvCxnSpPr>
+              <a:cxnSpLocks/>
+            </p:cNvCxnSpPr>
+            <p:nvPr/>
+          </p:nvCxnSpPr>
+          <p:spPr>
+            <a:xfrm>
+              <a:off x="587221" y="1939713"/>
+              <a:ext cx="445121" cy="0"/>
+            </a:xfrm>
+            <a:prstGeom prst="straightConnector1">
+              <a:avLst/>
+            </a:prstGeom>
+            <a:ln w="38100">
+              <a:tailEnd type="triangle"/>
+            </a:ln>
+          </p:spPr>
+          <p:style>
+            <a:lnRef idx="2">
+              <a:schemeClr val="dk1"/>
+            </a:lnRef>
+            <a:fillRef idx="0">
+              <a:schemeClr val="dk1"/>
+            </a:fillRef>
+            <a:effectRef idx="1">
+              <a:schemeClr val="dk1"/>
+            </a:effectRef>
+            <a:fontRef idx="minor">
+              <a:schemeClr val="tx1"/>
+            </a:fontRef>
+          </p:style>
+        </p:cxnSp>
+        <p:sp>
+          <p:nvSpPr>
+            <p:cNvPr id="20" name="TextBox 19">
+              <a:extLst>
+                <a:ext uri="{FF2B5EF4-FFF2-40B4-BE49-F238E27FC236}">
+                  <a16:creationId xmlns:a16="http://schemas.microsoft.com/office/drawing/2014/main" id="{1D8D0F1F-F38B-1394-6744-A557FE82A883}"/>
+                </a:ext>
+              </a:extLst>
+            </p:cNvPr>
+            <p:cNvSpPr txBox="1"/>
+            <p:nvPr/>
+          </p:nvSpPr>
+          <p:spPr>
+            <a:xfrm>
+              <a:off x="105587" y="1231703"/>
+              <a:ext cx="845376" cy="551477"/>
+            </a:xfrm>
+            <a:prstGeom prst="rect">
+              <a:avLst/>
+            </a:prstGeom>
+            <a:noFill/>
+          </p:spPr>
+          <p:txBody>
+            <a:bodyPr wrap="square" rtlCol="0">
+              <a:spAutoFit/>
+            </a:bodyPr>
+            <a:lstStyle/>
+            <a:p>
+              <a:r>
+                <a:rPr lang="en-US" sz="800" dirty="0"/>
+                <a:t>Categorical inputs</a:t>
+              </a:r>
+            </a:p>
+          </p:txBody>
+        </p:sp>
+        <p:sp>
+          <p:nvSpPr>
+            <p:cNvPr id="21" name="TextBox 20">
+              <a:extLst>
+                <a:ext uri="{FF2B5EF4-FFF2-40B4-BE49-F238E27FC236}">
+                  <a16:creationId xmlns:a16="http://schemas.microsoft.com/office/drawing/2014/main" id="{061B681A-EE19-06AF-0A63-83C61871DC2F}"/>
+                </a:ext>
+              </a:extLst>
+            </p:cNvPr>
+            <p:cNvSpPr txBox="1"/>
+            <p:nvPr/>
+          </p:nvSpPr>
+          <p:spPr>
+            <a:xfrm>
+              <a:off x="94327" y="1669442"/>
+              <a:ext cx="845376" cy="578440"/>
+            </a:xfrm>
+            <a:prstGeom prst="rect">
+              <a:avLst/>
+            </a:prstGeom>
+            <a:noFill/>
+          </p:spPr>
+          <p:txBody>
+            <a:bodyPr wrap="square" rtlCol="0">
+              <a:spAutoFit/>
+            </a:bodyPr>
+            <a:lstStyle/>
+            <a:p>
+              <a:r>
+                <a:rPr lang="en-US" sz="800" dirty="0"/>
+                <a:t>Contin-</a:t>
+              </a:r>
+              <a:r>
+                <a:rPr lang="en-US" sz="800" dirty="0" err="1"/>
+                <a:t>uous</a:t>
+              </a:r>
+              <a:r>
+                <a:rPr lang="en-US" sz="800" dirty="0"/>
+                <a:t> inputs</a:t>
+              </a:r>
+            </a:p>
+          </p:txBody>
+        </p:sp>
+        <p:cxnSp>
+          <p:nvCxnSpPr>
+            <p:cNvPr id="22" name="Straight Arrow Connector 21">
+              <a:extLst>
+                <a:ext uri="{FF2B5EF4-FFF2-40B4-BE49-F238E27FC236}">
+                  <a16:creationId xmlns:a16="http://schemas.microsoft.com/office/drawing/2014/main" id="{B0F411AB-8A6E-1387-5AD3-C65DA51AA104}"/>
+                </a:ext>
+              </a:extLst>
+            </p:cNvPr>
+            <p:cNvCxnSpPr>
+              <a:cxnSpLocks/>
+              <a:stCxn id="16" idx="3"/>
+              <a:endCxn id="17" idx="1"/>
+            </p:cNvCxnSpPr>
+            <p:nvPr/>
+          </p:nvCxnSpPr>
+          <p:spPr>
+            <a:xfrm>
+              <a:off x="1591876" y="1828800"/>
+              <a:ext cx="559536" cy="0"/>
+            </a:xfrm>
+            <a:prstGeom prst="straightConnector1">
+              <a:avLst/>
+            </a:prstGeom>
+            <a:ln w="38100">
+              <a:tailEnd type="triangle"/>
+            </a:ln>
+          </p:spPr>
+          <p:style>
+            <a:lnRef idx="2">
+              <a:schemeClr val="dk1"/>
+            </a:lnRef>
+            <a:fillRef idx="0">
+              <a:schemeClr val="dk1"/>
+            </a:fillRef>
+            <a:effectRef idx="1">
+              <a:schemeClr val="dk1"/>
+            </a:effectRef>
+            <a:fontRef idx="minor">
+              <a:schemeClr val="tx1"/>
+            </a:fontRef>
+          </p:style>
+        </p:cxnSp>
+        <p:sp>
+          <p:nvSpPr>
+            <p:cNvPr id="23" name="TextBox 22">
+              <a:extLst>
+                <a:ext uri="{FF2B5EF4-FFF2-40B4-BE49-F238E27FC236}">
+                  <a16:creationId xmlns:a16="http://schemas.microsoft.com/office/drawing/2014/main" id="{A7205DBC-F7C6-E888-5F28-3AAC33238B9D}"/>
+                </a:ext>
+              </a:extLst>
+            </p:cNvPr>
+            <p:cNvSpPr txBox="1"/>
+            <p:nvPr/>
+          </p:nvSpPr>
+          <p:spPr>
+            <a:xfrm>
+              <a:off x="1548481" y="1403442"/>
+              <a:ext cx="523493" cy="723081"/>
+            </a:xfrm>
+            <a:prstGeom prst="rect">
+              <a:avLst/>
+            </a:prstGeom>
+            <a:noFill/>
+          </p:spPr>
+          <p:txBody>
+            <a:bodyPr wrap="none" rtlCol="0">
+              <a:spAutoFit/>
+            </a:bodyPr>
+            <a:lstStyle/>
+            <a:p>
+              <a:pPr>
+                <a:lnSpc>
+                  <a:spcPct val="150000"/>
+                </a:lnSpc>
+              </a:pPr>
+              <a:r>
+                <a:rPr lang="en-US" sz="800" dirty="0"/>
+                <a:t>proto-</a:t>
+              </a:r>
+              <a:br>
+                <a:rPr lang="en-US" sz="800" dirty="0"/>
+              </a:br>
+              <a:r>
+                <a:rPr lang="en-US" sz="800" dirty="0"/>
+                <a:t>spectra</a:t>
+              </a:r>
+            </a:p>
+          </p:txBody>
+        </p:sp>
+        <p:cxnSp>
+          <p:nvCxnSpPr>
+            <p:cNvPr id="24" name="Straight Arrow Connector 23">
+              <a:extLst>
+                <a:ext uri="{FF2B5EF4-FFF2-40B4-BE49-F238E27FC236}">
+                  <a16:creationId xmlns:a16="http://schemas.microsoft.com/office/drawing/2014/main" id="{1C7487D3-4AE5-26E1-23E4-FBC2D99C0FC3}"/>
+                </a:ext>
+              </a:extLst>
+            </p:cNvPr>
+            <p:cNvCxnSpPr>
+              <a:stCxn id="17" idx="3"/>
+            </p:cNvCxnSpPr>
+            <p:nvPr/>
+          </p:nvCxnSpPr>
+          <p:spPr>
+            <a:xfrm>
+              <a:off x="2710949" y="1828800"/>
+              <a:ext cx="324502" cy="0"/>
+            </a:xfrm>
+            <a:prstGeom prst="straightConnector1">
+              <a:avLst/>
+            </a:prstGeom>
+            <a:ln w="38100">
+              <a:tailEnd type="triangle"/>
+            </a:ln>
+          </p:spPr>
+          <p:style>
+            <a:lnRef idx="2">
+              <a:schemeClr val="dk1"/>
+            </a:lnRef>
+            <a:fillRef idx="0">
+              <a:schemeClr val="dk1"/>
+            </a:fillRef>
+            <a:effectRef idx="1">
+              <a:schemeClr val="dk1"/>
+            </a:effectRef>
+            <a:fontRef idx="minor">
+              <a:schemeClr val="tx1"/>
+            </a:fontRef>
+          </p:style>
+        </p:cxnSp>
+        <p:sp>
+          <p:nvSpPr>
+            <p:cNvPr id="25" name="TextBox 24">
+              <a:extLst>
+                <a:ext uri="{FF2B5EF4-FFF2-40B4-BE49-F238E27FC236}">
+                  <a16:creationId xmlns:a16="http://schemas.microsoft.com/office/drawing/2014/main" id="{0A17FBB9-D8B0-4957-5601-7DD172C4EC02}"/>
+                </a:ext>
+              </a:extLst>
+            </p:cNvPr>
+            <p:cNvSpPr txBox="1"/>
+            <p:nvPr/>
+          </p:nvSpPr>
+          <p:spPr>
+            <a:xfrm>
+              <a:off x="2692956" y="1472664"/>
+              <a:ext cx="374244" cy="350940"/>
+            </a:xfrm>
+            <a:prstGeom prst="rect">
+              <a:avLst/>
+            </a:prstGeom>
+            <a:noFill/>
+          </p:spPr>
+          <p:txBody>
+            <a:bodyPr wrap="none" rtlCol="0">
+              <a:spAutoFit/>
+            </a:bodyPr>
+            <a:lstStyle/>
+            <a:p>
+              <a:r>
+                <a:rPr lang="en-US" sz="800" dirty="0"/>
+                <a:t>XRD</a:t>
+              </a:r>
+            </a:p>
+          </p:txBody>
+        </p:sp>
+      </p:grpSp>
+      <p:pic>
+        <p:nvPicPr>
+          <p:cNvPr id="26" name="Picture 25">
+            <a:extLst>
+              <a:ext uri="{FF2B5EF4-FFF2-40B4-BE49-F238E27FC236}">
+                <a16:creationId xmlns:a16="http://schemas.microsoft.com/office/drawing/2014/main" id="{AE65D038-8A43-4CD9-90A5-A4AA9A910E5E}"/>
+              </a:ext>
+            </a:extLst>
+          </p:cNvPr>
+          <p:cNvPicPr>
+            <a:picLocks noChangeAspect="1"/>
+          </p:cNvPicPr>
+          <p:nvPr/>
+        </p:nvPicPr>
+        <p:blipFill>
+          <a:blip/>
+          <a:srcRect t="4954"/>
+          <a:stretch>
+            <a:fillRect/>
+          </a:stretch>
+        </p:blipFill>
+        <p:spPr>
+          <a:xfrm>
+            <a:off x="1" y="1743077"/>
+            <a:ext cx="2478882" cy="1079478"/>
+          </a:xfrm>
+          <a:prstGeom prst="rect">
+            <a:avLst/>
+          </a:prstGeom>
+        </p:spPr>
+      </p:pic>
+      <p:pic>
+        <p:nvPicPr>
+          <p:cNvPr id="34" name="Picture 33">
+            <a:extLst>
+              <a:ext uri="{FF2B5EF4-FFF2-40B4-BE49-F238E27FC236}">
+                <a16:creationId xmlns:a16="http://schemas.microsoft.com/office/drawing/2014/main" id="{F7B199F2-B6F8-FECC-C17E-19F5EBD3F7C6}"/>
+              </a:ext>
+            </a:extLst>
+          </p:cNvPr>
+          <p:cNvPicPr>
+            <a:picLocks noChangeAspect="1"/>
+          </p:cNvPicPr>
+          <p:nvPr/>
+        </p:nvPicPr>
+        <p:blipFill>
+          <a:blip r:embed="rId3"/>
+          <a:stretch>
+            <a:fillRect/>
+          </a:stretch>
+        </p:blipFill>
+        <p:spPr>
+          <a:xfrm>
+            <a:off x="2452526" y="0"/>
+            <a:ext cx="1930400" cy="2844800"/>
+          </a:xfrm>
+          <a:prstGeom prst="rect">
+            <a:avLst/>
+          </a:prstGeom>
+        </p:spPr>
+      </p:pic>
+      <p:sp>
+        <p:nvSpPr>
+          <p:cNvPr id="35" name="TextBox 34">
+            <a:extLst>
+              <a:ext uri="{FF2B5EF4-FFF2-40B4-BE49-F238E27FC236}">
+                <a16:creationId xmlns:a16="http://schemas.microsoft.com/office/drawing/2014/main" id="{32E51B18-D61D-FCC0-F649-CA0DB2601C1E}"/>
+              </a:ext>
+            </a:extLst>
+          </p:cNvPr>
+          <p:cNvSpPr txBox="1"/>
+          <p:nvPr/>
+        </p:nvSpPr>
+        <p:spPr>
+          <a:xfrm>
+            <a:off x="-79328" y="-72615"/>
+            <a:ext cx="293670" cy="246221"/>
+          </a:xfrm>
+          <a:prstGeom prst="rect">
+            <a:avLst/>
+          </a:prstGeom>
+          <a:noFill/>
+        </p:spPr>
+        <p:txBody>
+          <a:bodyPr wrap="none" rtlCol="0">
+            <a:spAutoFit/>
+          </a:bodyPr>
+          <a:lstStyle/>
+          <a:p>
+            <a:r>
+              <a:rPr lang="en-US" sz="1000" b="1" dirty="0"/>
+              <a:t>a.</a:t>
+            </a:r>
+          </a:p>
+        </p:txBody>
+      </p:sp>
+      <p:sp>
+        <p:nvSpPr>
+          <p:cNvPr id="36" name="TextBox 35">
+            <a:extLst>
+              <a:ext uri="{FF2B5EF4-FFF2-40B4-BE49-F238E27FC236}">
+                <a16:creationId xmlns:a16="http://schemas.microsoft.com/office/drawing/2014/main" id="{A7374A3C-F2AB-50F3-BFDE-822D75E17BDA}"/>
+              </a:ext>
+            </a:extLst>
+          </p:cNvPr>
+          <p:cNvSpPr txBox="1"/>
+          <p:nvPr/>
+        </p:nvSpPr>
+        <p:spPr>
+          <a:xfrm>
+            <a:off x="-87914" y="460018"/>
+            <a:ext cx="298480" cy="246221"/>
+          </a:xfrm>
+          <a:prstGeom prst="rect">
+            <a:avLst/>
+          </a:prstGeom>
+          <a:noFill/>
+        </p:spPr>
+        <p:txBody>
+          <a:bodyPr wrap="none" rtlCol="0">
+            <a:spAutoFit/>
+          </a:bodyPr>
+          <a:lstStyle/>
+          <a:p>
+            <a:r>
+              <a:rPr lang="en-US" sz="1000" b="1" dirty="0"/>
+              <a:t>b.</a:t>
+            </a:r>
+          </a:p>
+        </p:txBody>
+      </p:sp>
+      <p:sp>
+        <p:nvSpPr>
+          <p:cNvPr id="37" name="TextBox 36">
+            <a:extLst>
+              <a:ext uri="{FF2B5EF4-FFF2-40B4-BE49-F238E27FC236}">
+                <a16:creationId xmlns:a16="http://schemas.microsoft.com/office/drawing/2014/main" id="{E1E34D25-071C-1483-465D-621E88FAE948}"/>
+              </a:ext>
+            </a:extLst>
+          </p:cNvPr>
+          <p:cNvSpPr txBox="1"/>
+          <p:nvPr/>
+        </p:nvSpPr>
+        <p:spPr>
+          <a:xfrm>
+            <a:off x="-87914" y="1667465"/>
+            <a:ext cx="293670" cy="246221"/>
+          </a:xfrm>
+          <a:prstGeom prst="rect">
+            <a:avLst/>
+          </a:prstGeom>
+          <a:noFill/>
+        </p:spPr>
+        <p:txBody>
+          <a:bodyPr wrap="none" rtlCol="0">
+            <a:spAutoFit/>
+          </a:bodyPr>
+          <a:lstStyle/>
+          <a:p>
+            <a:r>
+              <a:rPr lang="en-US" sz="1000" b="1" dirty="0"/>
+              <a:t>c.</a:t>
+            </a:r>
+          </a:p>
+        </p:txBody>
+      </p:sp>
+      <p:sp>
+        <p:nvSpPr>
+          <p:cNvPr id="38" name="TextBox 37">
+            <a:extLst>
+              <a:ext uri="{FF2B5EF4-FFF2-40B4-BE49-F238E27FC236}">
+                <a16:creationId xmlns:a16="http://schemas.microsoft.com/office/drawing/2014/main" id="{38CF9E20-5FC3-4852-F792-7DBBB6F723E4}"/>
+              </a:ext>
+            </a:extLst>
+          </p:cNvPr>
+          <p:cNvSpPr txBox="1"/>
+          <p:nvPr/>
+        </p:nvSpPr>
+        <p:spPr>
+          <a:xfrm>
+            <a:off x="2452526" y="-67112"/>
+            <a:ext cx="298480" cy="246221"/>
+          </a:xfrm>
+          <a:prstGeom prst="rect">
+            <a:avLst/>
+          </a:prstGeom>
+          <a:noFill/>
+        </p:spPr>
+        <p:txBody>
+          <a:bodyPr wrap="none" rtlCol="0">
+            <a:spAutoFit/>
+          </a:bodyPr>
+          <a:lstStyle/>
+          <a:p>
+            <a:r>
+              <a:rPr lang="en-US" sz="1000" b="1" dirty="0"/>
+              <a:t>d.</a:t>
+            </a:r>
+          </a:p>
+        </p:txBody>
+      </p:sp>
+      <p:sp>
+        <p:nvSpPr>
+          <p:cNvPr id="39" name="TextBox 38">
+            <a:extLst>
+              <a:ext uri="{FF2B5EF4-FFF2-40B4-BE49-F238E27FC236}">
+                <a16:creationId xmlns:a16="http://schemas.microsoft.com/office/drawing/2014/main" id="{CF2DBDBD-0D6A-306E-7944-D8783661C844}"/>
+              </a:ext>
+            </a:extLst>
+          </p:cNvPr>
+          <p:cNvSpPr txBox="1"/>
+          <p:nvPr/>
+        </p:nvSpPr>
+        <p:spPr>
+          <a:xfrm>
+            <a:off x="2452526" y="1391480"/>
+            <a:ext cx="293670" cy="246221"/>
+          </a:xfrm>
+          <a:prstGeom prst="rect">
+            <a:avLst/>
+          </a:prstGeom>
+          <a:noFill/>
+        </p:spPr>
+        <p:txBody>
+          <a:bodyPr wrap="none" rtlCol="0">
+            <a:spAutoFit/>
+          </a:bodyPr>
+          <a:lstStyle/>
+          <a:p>
+            <a:r>
+              <a:rPr lang="en-US" sz="1000" b="1" dirty="0"/>
+              <a:t>e.</a:t>
+            </a:r>
+          </a:p>
+        </p:txBody>
+      </p:sp>
+    </p:spTree>
+    <p:extLst>
+      <p:ext uri="{BB962C8B-B14F-4D97-AF65-F5344CB8AC3E}">
+        <p14:creationId xmlns:p14="http://schemas.microsoft.com/office/powerpoint/2010/main" val="3391518357"/>
       </p:ext>
     </p:extLst>
   </p:cSld>

</xml_diff>